<commit_message>
Simplify technical details slides to match main presentation style
Rewrite all three slides to be clean and minimal:
- Slide 1: Dipole methods - simple formulas and bullet points
- Slide 2: Mode matching - concise problem/solution/example
- Slide 3: Parsing - focus on key challenges, not exhaustive details

Match mace_gaussian_presentation.pptx style:
- Short bullet points with arrows (→)
- Clean whitespace
- Simple section headers (#)
- 14pt body text, 28pt titles
- No walls of text
</commit_message>
<xml_diff>
--- a/presentation/technical_details.pptx
+++ b/presentation/technical_details.pptx
@@ -3106,7 +3106,7 @@
         </p:nvSpPr>
         <p:spPr>
           <a:xfrm>
-            <a:off x="457200" y="274320"/>
+            <a:off x="457200" y="365760"/>
             <a:ext cx="8229600" cy="457200"/>
           </a:xfrm>
           <a:prstGeom prst="rect">
@@ -3121,7 +3121,7 @@
           <a:lstStyle/>
           <a:p>
             <a:pPr>
-              <a:defRPr sz="2400" b="1">
+              <a:defRPr sz="2800" b="1">
                 <a:solidFill>
                   <a:srgbClr val="58A6FF"/>
                 </a:solidFill>
@@ -3129,7 +3129,7 @@
               </a:defRPr>
             </a:pPr>
             <a:r>
-              <a:t>$ cat dipole_calculation_methods.txt</a:t>
+              <a:t>$ cat dipole_methods.md</a:t>
             </a:r>
           </a:p>
         </p:txBody>
@@ -3142,8 +3142,8 @@
         </p:nvSpPr>
         <p:spPr>
           <a:xfrm>
-            <a:off x="457200" y="914400"/>
-            <a:ext cx="8229600" cy="5486400"/>
+            <a:off x="731520" y="1097280"/>
+            <a:ext cx="7680960" cy="4389120"/>
           </a:xfrm>
           <a:prstGeom prst="rect">
             <a:avLst/>
@@ -3161,9 +3161,9 @@
                 <a:spcPct val="100000"/>
               </a:lnSpc>
               <a:spcAft>
-                <a:spcPts val="0"/>
-              </a:spcAft>
-              <a:defRPr sz="900">
+                <a:spcPts val="600"/>
+              </a:spcAft>
+              <a:defRPr sz="1400">
                 <a:solidFill>
                   <a:srgbClr val="58A6FF"/>
                 </a:solidFill>
@@ -3171,18 +3171,34 @@
               </a:defRPr>
             </a:pPr>
             <a:r>
-              <a:t>DIPOLE MOMENT CALCULATION METHODS</a:t>
-            </a:r>
-          </a:p>
-          <a:p>
-            <a:pPr>
-              <a:lnSpc>
-                <a:spcPct val="100000"/>
-              </a:lnSpc>
-              <a:spcAft>
-                <a:spcPts val="0"/>
-              </a:spcAft>
-              <a:defRPr sz="900">
+              <a:t># MACE-ML (Direct Prediction)</a:t>
+            </a:r>
+          </a:p>
+          <a:p>
+            <a:pPr>
+              <a:lnSpc>
+                <a:spcPct val="100000"/>
+              </a:lnSpc>
+              <a:spcAft>
+                <a:spcPts val="600"/>
+              </a:spcAft>
+              <a:defRPr sz="1400">
+                <a:solidFill>
+                  <a:srgbClr val="C9D1D9"/>
+                </a:solidFill>
+                <a:latin typeface="Consolas"/>
+              </a:defRPr>
+            </a:pPr>
+          </a:p>
+          <a:p>
+            <a:pPr>
+              <a:lnSpc>
+                <a:spcPct val="100000"/>
+              </a:lnSpc>
+              <a:spcAft>
+                <a:spcPts val="600"/>
+              </a:spcAft>
+              <a:defRPr sz="1400">
                 <a:solidFill>
                   <a:srgbClr val="8B949E"/>
                 </a:solidFill>
@@ -3190,18 +3206,18 @@
               </a:defRPr>
             </a:pPr>
             <a:r>
-              <a:t>═════════════════════════════════════════════════════════════════════════</a:t>
-            </a:r>
-          </a:p>
-          <a:p>
-            <a:pPr>
-              <a:lnSpc>
-                <a:spcPct val="100000"/>
-              </a:lnSpc>
-              <a:spcAft>
-                <a:spcPts val="0"/>
-              </a:spcAft>
-              <a:defRPr sz="900">
+              <a:t>  Input → E(3)-equivariant NN → μ = (μx, μy, μz)</a:t>
+            </a:r>
+          </a:p>
+          <a:p>
+            <a:pPr>
+              <a:lnSpc>
+                <a:spcPct val="100000"/>
+              </a:lnSpc>
+              <a:spcAft>
+                <a:spcPts val="600"/>
+              </a:spcAft>
+              <a:defRPr sz="1400">
                 <a:solidFill>
                   <a:srgbClr val="C9D1D9"/>
                 </a:solidFill>
@@ -3215,28 +3231,133 @@
                 <a:spcPct val="100000"/>
               </a:lnSpc>
               <a:spcAft>
-                <a:spcPts val="0"/>
-              </a:spcAft>
-              <a:defRPr sz="900">
-                <a:solidFill>
-                  <a:srgbClr val="DB6D28"/>
-                </a:solidFill>
-                <a:latin typeface="Consolas"/>
-              </a:defRPr>
-            </a:pPr>
-            <a:r>
-              <a:t>1. MACE-ML (Custom Dipole-Enabled MACE)</a:t>
-            </a:r>
-          </a:p>
-          <a:p>
-            <a:pPr>
-              <a:lnSpc>
-                <a:spcPct val="100000"/>
-              </a:lnSpc>
-              <a:spcAft>
-                <a:spcPts val="0"/>
-              </a:spcAft>
-              <a:defRPr sz="900">
+                <a:spcPts val="600"/>
+              </a:spcAft>
+              <a:defRPr sz="1400">
+                <a:solidFill>
+                  <a:srgbClr val="C9D1D9"/>
+                </a:solidFill>
+                <a:latin typeface="Consolas"/>
+              </a:defRPr>
+            </a:pPr>
+            <a:r>
+              <a:t>  → Direct dipole prediction</a:t>
+            </a:r>
+          </a:p>
+          <a:p>
+            <a:pPr>
+              <a:lnSpc>
+                <a:spcPct val="100000"/>
+              </a:lnSpc>
+              <a:spcAft>
+                <a:spcPts val="600"/>
+              </a:spcAft>
+              <a:defRPr sz="1400">
+                <a:solidFill>
+                  <a:srgbClr val="C9D1D9"/>
+                </a:solidFill>
+                <a:latin typeface="Consolas"/>
+              </a:defRPr>
+            </a:pPr>
+            <a:r>
+              <a:t>  → Fast (~0.1s per geometry)</a:t>
+            </a:r>
+          </a:p>
+          <a:p>
+            <a:pPr>
+              <a:lnSpc>
+                <a:spcPct val="100000"/>
+              </a:lnSpc>
+              <a:spcAft>
+                <a:spcPts val="600"/>
+              </a:spcAft>
+              <a:defRPr sz="1400">
+                <a:solidFill>
+                  <a:srgbClr val="C9D1D9"/>
+                </a:solidFill>
+                <a:latin typeface="Consolas"/>
+              </a:defRPr>
+            </a:pPr>
+            <a:r>
+              <a:t>  → Requires custom model</a:t>
+            </a:r>
+          </a:p>
+          <a:p>
+            <a:pPr>
+              <a:lnSpc>
+                <a:spcPct val="100000"/>
+              </a:lnSpc>
+              <a:spcAft>
+                <a:spcPts val="600"/>
+              </a:spcAft>
+              <a:defRPr sz="1400">
+                <a:solidFill>
+                  <a:srgbClr val="C9D1D9"/>
+                </a:solidFill>
+                <a:latin typeface="Consolas"/>
+              </a:defRPr>
+            </a:pPr>
+          </a:p>
+          <a:p>
+            <a:pPr>
+              <a:lnSpc>
+                <a:spcPct val="100000"/>
+              </a:lnSpc>
+              <a:spcAft>
+                <a:spcPts val="600"/>
+              </a:spcAft>
+              <a:defRPr sz="1400">
+                <a:solidFill>
+                  <a:srgbClr val="C9D1D9"/>
+                </a:solidFill>
+                <a:latin typeface="Consolas"/>
+              </a:defRPr>
+            </a:pPr>
+          </a:p>
+          <a:p>
+            <a:pPr>
+              <a:lnSpc>
+                <a:spcPct val="100000"/>
+              </a:lnSpc>
+              <a:spcAft>
+                <a:spcPts val="600"/>
+              </a:spcAft>
+              <a:defRPr sz="1400">
+                <a:solidFill>
+                  <a:srgbClr val="58A6FF"/>
+                </a:solidFill>
+                <a:latin typeface="Consolas"/>
+              </a:defRPr>
+            </a:pPr>
+            <a:r>
+              <a:t># Espaloma (Charge-Based)</a:t>
+            </a:r>
+          </a:p>
+          <a:p>
+            <a:pPr>
+              <a:lnSpc>
+                <a:spcPct val="100000"/>
+              </a:lnSpc>
+              <a:spcAft>
+                <a:spcPts val="600"/>
+              </a:spcAft>
+              <a:defRPr sz="1400">
+                <a:solidFill>
+                  <a:srgbClr val="C9D1D9"/>
+                </a:solidFill>
+                <a:latin typeface="Consolas"/>
+              </a:defRPr>
+            </a:pPr>
+          </a:p>
+          <a:p>
+            <a:pPr>
+              <a:lnSpc>
+                <a:spcPct val="100000"/>
+              </a:lnSpc>
+              <a:spcAft>
+                <a:spcPts val="600"/>
+              </a:spcAft>
+              <a:defRPr sz="1400">
                 <a:solidFill>
                   <a:srgbClr val="8B949E"/>
                 </a:solidFill>
@@ -3244,37 +3365,142 @@
               </a:defRPr>
             </a:pPr>
             <a:r>
-              <a:t>   ─────────────────────────────────────</a:t>
-            </a:r>
-          </a:p>
-          <a:p>
-            <a:pPr>
-              <a:lnSpc>
-                <a:spcPct val="100000"/>
-              </a:lnSpc>
-              <a:spcAft>
-                <a:spcPts val="0"/>
-              </a:spcAft>
-              <a:defRPr sz="900">
+              <a:t>  Predict charges → μ = Σ qᵢ·rᵢ</a:t>
+            </a:r>
+          </a:p>
+          <a:p>
+            <a:pPr>
+              <a:lnSpc>
+                <a:spcPct val="100000"/>
+              </a:lnSpc>
+              <a:spcAft>
+                <a:spcPts val="600"/>
+              </a:spcAft>
+              <a:defRPr sz="1400">
                 <a:solidFill>
                   <a:srgbClr val="C9D1D9"/>
                 </a:solidFill>
                 <a:latin typeface="Consolas"/>
               </a:defRPr>
             </a:pPr>
-            <a:r>
-              <a:t>   Model: DipolePolarizabilityMACE</a:t>
-            </a:r>
-          </a:p>
-          <a:p>
-            <a:pPr>
-              <a:lnSpc>
-                <a:spcPct val="100000"/>
-              </a:lnSpc>
-              <a:spcAft>
-                <a:spcPts val="0"/>
-              </a:spcAft>
-              <a:defRPr sz="900">
+          </a:p>
+          <a:p>
+            <a:pPr>
+              <a:lnSpc>
+                <a:spcPct val="100000"/>
+              </a:lnSpc>
+              <a:spcAft>
+                <a:spcPts val="600"/>
+              </a:spcAft>
+              <a:defRPr sz="1400">
+                <a:solidFill>
+                  <a:srgbClr val="C9D1D9"/>
+                </a:solidFill>
+                <a:latin typeface="Consolas"/>
+              </a:defRPr>
+            </a:pPr>
+            <a:r>
+              <a:t>  → ML partial charges (q₁, q₂, ..., qₙ)</a:t>
+            </a:r>
+          </a:p>
+          <a:p>
+            <a:pPr>
+              <a:lnSpc>
+                <a:spcPct val="100000"/>
+              </a:lnSpc>
+              <a:spcAft>
+                <a:spcPts val="600"/>
+              </a:spcAft>
+              <a:defRPr sz="1400">
+                <a:solidFill>
+                  <a:srgbClr val="C9D1D9"/>
+                </a:solidFill>
+                <a:latin typeface="Consolas"/>
+              </a:defRPr>
+            </a:pPr>
+            <a:r>
+              <a:t>  → Sum over atomic positions</a:t>
+            </a:r>
+          </a:p>
+          <a:p>
+            <a:pPr>
+              <a:lnSpc>
+                <a:spcPct val="100000"/>
+              </a:lnSpc>
+              <a:spcAft>
+                <a:spcPts val="600"/>
+              </a:spcAft>
+              <a:defRPr sz="1400">
+                <a:solidFill>
+                  <a:srgbClr val="C9D1D9"/>
+                </a:solidFill>
+                <a:latin typeface="Consolas"/>
+              </a:defRPr>
+            </a:pPr>
+            <a:r>
+              <a:t>  → Widely available, interpretable</a:t>
+            </a:r>
+          </a:p>
+          <a:p>
+            <a:pPr>
+              <a:lnSpc>
+                <a:spcPct val="100000"/>
+              </a:lnSpc>
+              <a:spcAft>
+                <a:spcPts val="600"/>
+              </a:spcAft>
+              <a:defRPr sz="1400">
+                <a:solidFill>
+                  <a:srgbClr val="C9D1D9"/>
+                </a:solidFill>
+                <a:latin typeface="Consolas"/>
+              </a:defRPr>
+            </a:pPr>
+          </a:p>
+          <a:p>
+            <a:pPr>
+              <a:lnSpc>
+                <a:spcPct val="100000"/>
+              </a:lnSpc>
+              <a:spcAft>
+                <a:spcPts val="600"/>
+              </a:spcAft>
+              <a:defRPr sz="1400">
+                <a:solidFill>
+                  <a:srgbClr val="C9D1D9"/>
+                </a:solidFill>
+                <a:latin typeface="Consolas"/>
+              </a:defRPr>
+            </a:pPr>
+          </a:p>
+          <a:p>
+            <a:pPr>
+              <a:lnSpc>
+                <a:spcPct val="100000"/>
+              </a:lnSpc>
+              <a:spcAft>
+                <a:spcPts val="600"/>
+              </a:spcAft>
+              <a:defRPr sz="1400">
+                <a:solidFill>
+                  <a:srgbClr val="58A6FF"/>
+                </a:solidFill>
+                <a:latin typeface="Consolas"/>
+              </a:defRPr>
+            </a:pPr>
+            <a:r>
+              <a:t># Fallback Chain</a:t>
+            </a:r>
+          </a:p>
+          <a:p>
+            <a:pPr>
+              <a:lnSpc>
+                <a:spcPct val="100000"/>
+              </a:lnSpc>
+              <a:spcAft>
+                <a:spcPts val="600"/>
+              </a:spcAft>
+              <a:defRPr sz="1400">
                 <a:solidFill>
                   <a:srgbClr val="8B949E"/>
                 </a:solidFill>
@@ -3282,686 +3508,7 @@
               </a:defRPr>
             </a:pPr>
             <a:r>
-              <a:t>   Path:  ~/mace_gaussian/dipole_model/model_1.model</a:t>
-            </a:r>
-          </a:p>
-          <a:p>
-            <a:pPr>
-              <a:lnSpc>
-                <a:spcPct val="100000"/>
-              </a:lnSpc>
-              <a:spcAft>
-                <a:spcPts val="0"/>
-              </a:spcAft>
-              <a:defRPr sz="900">
-                <a:solidFill>
-                  <a:srgbClr val="C9D1D9"/>
-                </a:solidFill>
-                <a:latin typeface="Consolas"/>
-              </a:defRPr>
-            </a:pPr>
-          </a:p>
-          <a:p>
-            <a:pPr>
-              <a:lnSpc>
-                <a:spcPct val="100000"/>
-              </a:lnSpc>
-              <a:spcAft>
-                <a:spcPts val="0"/>
-              </a:spcAft>
-              <a:defRPr sz="900">
-                <a:solidFill>
-                  <a:srgbClr val="C9D1D9"/>
-                </a:solidFill>
-                <a:latin typeface="Consolas"/>
-              </a:defRPr>
-            </a:pPr>
-            <a:r>
-              <a:t>   Architecture:</a:t>
-            </a:r>
-          </a:p>
-          <a:p>
-            <a:pPr>
-              <a:lnSpc>
-                <a:spcPct val="100000"/>
-              </a:lnSpc>
-              <a:spcAft>
-                <a:spcPts val="0"/>
-              </a:spcAft>
-              <a:defRPr sz="900">
-                <a:solidFill>
-                  <a:srgbClr val="58A6FF"/>
-                </a:solidFill>
-                <a:latin typeface="Consolas"/>
-              </a:defRPr>
-            </a:pPr>
-            <a:r>
-              <a:t>   ┌──────────────────────────────────────────────────────────────┐</a:t>
-            </a:r>
-          </a:p>
-          <a:p>
-            <a:pPr>
-              <a:lnSpc>
-                <a:spcPct val="100000"/>
-              </a:lnSpc>
-              <a:spcAft>
-                <a:spcPts val="0"/>
-              </a:spcAft>
-              <a:defRPr sz="900">
-                <a:solidFill>
-                  <a:srgbClr val="C9D1D9"/>
-                </a:solidFill>
-                <a:latin typeface="Consolas"/>
-              </a:defRPr>
-            </a:pPr>
-            <a:r>
-              <a:t>   │  Input: Atomic coordinates (x, y, z) + atomic numbers       │</a:t>
-            </a:r>
-          </a:p>
-          <a:p>
-            <a:pPr>
-              <a:lnSpc>
-                <a:spcPct val="100000"/>
-              </a:lnSpc>
-              <a:spcAft>
-                <a:spcPts val="0"/>
-              </a:spcAft>
-              <a:defRPr sz="900">
-                <a:solidFill>
-                  <a:srgbClr val="8B949E"/>
-                </a:solidFill>
-                <a:latin typeface="Consolas"/>
-              </a:defRPr>
-            </a:pPr>
-            <a:r>
-              <a:t>   │         ↓                                                    │</a:t>
-            </a:r>
-          </a:p>
-          <a:p>
-            <a:pPr>
-              <a:lnSpc>
-                <a:spcPct val="100000"/>
-              </a:lnSpc>
-              <a:spcAft>
-                <a:spcPts val="0"/>
-              </a:spcAft>
-              <a:defRPr sz="900">
-                <a:solidFill>
-                  <a:srgbClr val="C9D1D9"/>
-                </a:solidFill>
-                <a:latin typeface="Consolas"/>
-              </a:defRPr>
-            </a:pPr>
-            <a:r>
-              <a:t>   │  E(3)-equivariant message passing layers                    │</a:t>
-            </a:r>
-          </a:p>
-          <a:p>
-            <a:pPr>
-              <a:lnSpc>
-                <a:spcPct val="100000"/>
-              </a:lnSpc>
-              <a:spcAft>
-                <a:spcPts val="0"/>
-              </a:spcAft>
-              <a:defRPr sz="900">
-                <a:solidFill>
-                  <a:srgbClr val="8B949E"/>
-                </a:solidFill>
-                <a:latin typeface="Consolas"/>
-              </a:defRPr>
-            </a:pPr>
-            <a:r>
-              <a:t>   │         ↓                                                    │</a:t>
-            </a:r>
-          </a:p>
-          <a:p>
-            <a:pPr>
-              <a:lnSpc>
-                <a:spcPct val="100000"/>
-              </a:lnSpc>
-              <a:spcAft>
-                <a:spcPts val="0"/>
-              </a:spcAft>
-              <a:defRPr sz="900">
-                <a:solidFill>
-                  <a:srgbClr val="57AB5A"/>
-                </a:solidFill>
-                <a:latin typeface="Consolas"/>
-              </a:defRPr>
-            </a:pPr>
-            <a:r>
-              <a:t>   │  Output: μ = (μx, μy, μz)  [Debye]                          │</a:t>
-            </a:r>
-          </a:p>
-          <a:p>
-            <a:pPr>
-              <a:lnSpc>
-                <a:spcPct val="100000"/>
-              </a:lnSpc>
-              <a:spcAft>
-                <a:spcPts val="0"/>
-              </a:spcAft>
-              <a:defRPr sz="900">
-                <a:solidFill>
-                  <a:srgbClr val="C9D1D9"/>
-                </a:solidFill>
-                <a:latin typeface="Consolas"/>
-              </a:defRPr>
-            </a:pPr>
-            <a:r>
-              <a:t>   │          Direct prediction of molecular dipole moment        │</a:t>
-            </a:r>
-          </a:p>
-          <a:p>
-            <a:pPr>
-              <a:lnSpc>
-                <a:spcPct val="100000"/>
-              </a:lnSpc>
-              <a:spcAft>
-                <a:spcPts val="0"/>
-              </a:spcAft>
-              <a:defRPr sz="900">
-                <a:solidFill>
-                  <a:srgbClr val="58A6FF"/>
-                </a:solidFill>
-                <a:latin typeface="Consolas"/>
-              </a:defRPr>
-            </a:pPr>
-            <a:r>
-              <a:t>   └──────────────────────────────────────────────────────────────┘</a:t>
-            </a:r>
-          </a:p>
-          <a:p>
-            <a:pPr>
-              <a:lnSpc>
-                <a:spcPct val="100000"/>
-              </a:lnSpc>
-              <a:spcAft>
-                <a:spcPts val="0"/>
-              </a:spcAft>
-              <a:defRPr sz="900">
-                <a:solidFill>
-                  <a:srgbClr val="C9D1D9"/>
-                </a:solidFill>
-                <a:latin typeface="Consolas"/>
-              </a:defRPr>
-            </a:pPr>
-          </a:p>
-          <a:p>
-            <a:pPr>
-              <a:lnSpc>
-                <a:spcPct val="100000"/>
-              </a:lnSpc>
-              <a:spcAft>
-                <a:spcPts val="0"/>
-              </a:spcAft>
-              <a:defRPr sz="900">
-                <a:solidFill>
-                  <a:srgbClr val="C9D1D9"/>
-                </a:solidFill>
-                <a:latin typeface="Consolas"/>
-              </a:defRPr>
-            </a:pPr>
-            <a:r>
-              <a:t>   Advantages: Fast (~0.1s per geometry), physically consistent</a:t>
-            </a:r>
-          </a:p>
-          <a:p>
-            <a:pPr>
-              <a:lnSpc>
-                <a:spcPct val="100000"/>
-              </a:lnSpc>
-              <a:spcAft>
-                <a:spcPts val="0"/>
-              </a:spcAft>
-              <a:defRPr sz="900">
-                <a:solidFill>
-                  <a:srgbClr val="8B949E"/>
-                </a:solidFill>
-                <a:latin typeface="Consolas"/>
-              </a:defRPr>
-            </a:pPr>
-            <a:r>
-              <a:t>   Limitations: Requires custom-trained model</a:t>
-            </a:r>
-          </a:p>
-          <a:p>
-            <a:pPr>
-              <a:lnSpc>
-                <a:spcPct val="100000"/>
-              </a:lnSpc>
-              <a:spcAft>
-                <a:spcPts val="0"/>
-              </a:spcAft>
-              <a:defRPr sz="900">
-                <a:solidFill>
-                  <a:srgbClr val="C9D1D9"/>
-                </a:solidFill>
-                <a:latin typeface="Consolas"/>
-              </a:defRPr>
-            </a:pPr>
-          </a:p>
-          <a:p>
-            <a:pPr>
-              <a:lnSpc>
-                <a:spcPct val="100000"/>
-              </a:lnSpc>
-              <a:spcAft>
-                <a:spcPts val="0"/>
-              </a:spcAft>
-              <a:defRPr sz="900">
-                <a:solidFill>
-                  <a:srgbClr val="C9D1D9"/>
-                </a:solidFill>
-                <a:latin typeface="Consolas"/>
-              </a:defRPr>
-            </a:pPr>
-          </a:p>
-          <a:p>
-            <a:pPr>
-              <a:lnSpc>
-                <a:spcPct val="100000"/>
-              </a:lnSpc>
-              <a:spcAft>
-                <a:spcPts val="0"/>
-              </a:spcAft>
-              <a:defRPr sz="900">
-                <a:solidFill>
-                  <a:srgbClr val="DB6D28"/>
-                </a:solidFill>
-                <a:latin typeface="Consolas"/>
-              </a:defRPr>
-            </a:pPr>
-            <a:r>
-              <a:t>2. ESPALOMA (Charge-Based Approach)</a:t>
-            </a:r>
-          </a:p>
-          <a:p>
-            <a:pPr>
-              <a:lnSpc>
-                <a:spcPct val="100000"/>
-              </a:lnSpc>
-              <a:spcAft>
-                <a:spcPts val="0"/>
-              </a:spcAft>
-              <a:defRPr sz="900">
-                <a:solidFill>
-                  <a:srgbClr val="8B949E"/>
-                </a:solidFill>
-                <a:latin typeface="Consolas"/>
-              </a:defRPr>
-            </a:pPr>
-            <a:r>
-              <a:t>   ──────────────────────────────────</a:t>
-            </a:r>
-          </a:p>
-          <a:p>
-            <a:pPr>
-              <a:lnSpc>
-                <a:spcPct val="100000"/>
-              </a:lnSpc>
-              <a:spcAft>
-                <a:spcPts val="0"/>
-              </a:spcAft>
-              <a:defRPr sz="900">
-                <a:solidFill>
-                  <a:srgbClr val="C9D1D9"/>
-                </a:solidFill>
-                <a:latin typeface="Consolas"/>
-              </a:defRPr>
-            </a:pPr>
-            <a:r>
-              <a:t>   Method: Atomic partial charges from graph neural network</a:t>
-            </a:r>
-          </a:p>
-          <a:p>
-            <a:pPr>
-              <a:lnSpc>
-                <a:spcPct val="100000"/>
-              </a:lnSpc>
-              <a:spcAft>
-                <a:spcPts val="0"/>
-              </a:spcAft>
-              <a:defRPr sz="900">
-                <a:solidFill>
-                  <a:srgbClr val="C9D1D9"/>
-                </a:solidFill>
-                <a:latin typeface="Consolas"/>
-              </a:defRPr>
-            </a:pPr>
-          </a:p>
-          <a:p>
-            <a:pPr>
-              <a:lnSpc>
-                <a:spcPct val="100000"/>
-              </a:lnSpc>
-              <a:spcAft>
-                <a:spcPts val="0"/>
-              </a:spcAft>
-              <a:defRPr sz="900">
-                <a:solidFill>
-                  <a:srgbClr val="C9D1D9"/>
-                </a:solidFill>
-                <a:latin typeface="Consolas"/>
-              </a:defRPr>
-            </a:pPr>
-            <a:r>
-              <a:t>   Algorithm:</a:t>
-            </a:r>
-          </a:p>
-          <a:p>
-            <a:pPr>
-              <a:lnSpc>
-                <a:spcPct val="100000"/>
-              </a:lnSpc>
-              <a:spcAft>
-                <a:spcPts val="0"/>
-              </a:spcAft>
-              <a:defRPr sz="900">
-                <a:solidFill>
-                  <a:srgbClr val="58A6FF"/>
-                </a:solidFill>
-                <a:latin typeface="Consolas"/>
-              </a:defRPr>
-            </a:pPr>
-            <a:r>
-              <a:t>   ┌──────────────────────────────────────────────────────────────┐</a:t>
-            </a:r>
-          </a:p>
-          <a:p>
-            <a:pPr>
-              <a:lnSpc>
-                <a:spcPct val="100000"/>
-              </a:lnSpc>
-              <a:spcAft>
-                <a:spcPts val="0"/>
-              </a:spcAft>
-              <a:defRPr sz="900">
-                <a:solidFill>
-                  <a:srgbClr val="C9D1D9"/>
-                </a:solidFill>
-                <a:latin typeface="Consolas"/>
-              </a:defRPr>
-            </a:pPr>
-            <a:r>
-              <a:t>   │  1. Predict partial charges: q₁, q₂, ..., qₙ               │</a:t>
-            </a:r>
-          </a:p>
-          <a:p>
-            <a:pPr>
-              <a:lnSpc>
-                <a:spcPct val="100000"/>
-              </a:lnSpc>
-              <a:spcAft>
-                <a:spcPts val="0"/>
-              </a:spcAft>
-              <a:defRPr sz="900">
-                <a:solidFill>
-                  <a:srgbClr val="C9D1D9"/>
-                </a:solidFill>
-                <a:latin typeface="Consolas"/>
-              </a:defRPr>
-            </a:pPr>
-            <a:r>
-              <a:t>   │                                                              │</a:t>
-            </a:r>
-          </a:p>
-          <a:p>
-            <a:pPr>
-              <a:lnSpc>
-                <a:spcPct val="100000"/>
-              </a:lnSpc>
-              <a:spcAft>
-                <a:spcPts val="0"/>
-              </a:spcAft>
-              <a:defRPr sz="900">
-                <a:solidFill>
-                  <a:srgbClr val="C9D1D9"/>
-                </a:solidFill>
-                <a:latin typeface="Consolas"/>
-              </a:defRPr>
-            </a:pPr>
-            <a:r>
-              <a:t>   │  2. Calculate dipole moment:                                │</a:t>
-            </a:r>
-          </a:p>
-          <a:p>
-            <a:pPr>
-              <a:lnSpc>
-                <a:spcPct val="100000"/>
-              </a:lnSpc>
-              <a:spcAft>
-                <a:spcPts val="0"/>
-              </a:spcAft>
-              <a:defRPr sz="900">
-                <a:solidFill>
-                  <a:srgbClr val="C9D1D9"/>
-                </a:solidFill>
-                <a:latin typeface="Consolas"/>
-              </a:defRPr>
-            </a:pPr>
-            <a:r>
-              <a:t>   │                        n                                     │</a:t>
-            </a:r>
-          </a:p>
-          <a:p>
-            <a:pPr>
-              <a:lnSpc>
-                <a:spcPct val="100000"/>
-              </a:lnSpc>
-              <a:spcAft>
-                <a:spcPts val="0"/>
-              </a:spcAft>
-              <a:defRPr sz="900">
-                <a:solidFill>
-                  <a:srgbClr val="57AB5A"/>
-                </a:solidFill>
-                <a:latin typeface="Consolas"/>
-              </a:defRPr>
-            </a:pPr>
-            <a:r>
-              <a:t>   │     μ = Σ qᵢ · rᵢ     (vector sum)                          │</a:t>
-            </a:r>
-          </a:p>
-          <a:p>
-            <a:pPr>
-              <a:lnSpc>
-                <a:spcPct val="100000"/>
-              </a:lnSpc>
-              <a:spcAft>
-                <a:spcPts val="0"/>
-              </a:spcAft>
-              <a:defRPr sz="900">
-                <a:solidFill>
-                  <a:srgbClr val="C9D1D9"/>
-                </a:solidFill>
-                <a:latin typeface="Consolas"/>
-              </a:defRPr>
-            </a:pPr>
-            <a:r>
-              <a:t>   │        i=1                                                   │</a:t>
-            </a:r>
-          </a:p>
-          <a:p>
-            <a:pPr>
-              <a:lnSpc>
-                <a:spcPct val="100000"/>
-              </a:lnSpc>
-              <a:spcAft>
-                <a:spcPts val="0"/>
-              </a:spcAft>
-              <a:defRPr sz="900">
-                <a:solidFill>
-                  <a:srgbClr val="C9D1D9"/>
-                </a:solidFill>
-                <a:latin typeface="Consolas"/>
-              </a:defRPr>
-            </a:pPr>
-            <a:r>
-              <a:t>   │                                                              │</a:t>
-            </a:r>
-          </a:p>
-          <a:p>
-            <a:pPr>
-              <a:lnSpc>
-                <a:spcPct val="100000"/>
-              </a:lnSpc>
-              <a:spcAft>
-                <a:spcPts val="0"/>
-              </a:spcAft>
-              <a:defRPr sz="900">
-                <a:solidFill>
-                  <a:srgbClr val="8B949E"/>
-                </a:solidFill>
-                <a:latin typeface="Consolas"/>
-              </a:defRPr>
-            </a:pPr>
-            <a:r>
-              <a:t>   │     where: qᵢ = partial charge on atom i                    │</a:t>
-            </a:r>
-          </a:p>
-          <a:p>
-            <a:pPr>
-              <a:lnSpc>
-                <a:spcPct val="100000"/>
-              </a:lnSpc>
-              <a:spcAft>
-                <a:spcPts val="0"/>
-              </a:spcAft>
-              <a:defRPr sz="900">
-                <a:solidFill>
-                  <a:srgbClr val="8B949E"/>
-                </a:solidFill>
-                <a:latin typeface="Consolas"/>
-              </a:defRPr>
-            </a:pPr>
-            <a:r>
-              <a:t>   │            rᵢ = position vector of atom i                   │</a:t>
-            </a:r>
-          </a:p>
-          <a:p>
-            <a:pPr>
-              <a:lnSpc>
-                <a:spcPct val="100000"/>
-              </a:lnSpc>
-              <a:spcAft>
-                <a:spcPts val="0"/>
-              </a:spcAft>
-              <a:defRPr sz="900">
-                <a:solidFill>
-                  <a:srgbClr val="58A6FF"/>
-                </a:solidFill>
-                <a:latin typeface="Consolas"/>
-              </a:defRPr>
-            </a:pPr>
-            <a:r>
-              <a:t>   └──────────────────────────────────────────────────────────────┘</a:t>
-            </a:r>
-          </a:p>
-          <a:p>
-            <a:pPr>
-              <a:lnSpc>
-                <a:spcPct val="100000"/>
-              </a:lnSpc>
-              <a:spcAft>
-                <a:spcPts val="0"/>
-              </a:spcAft>
-              <a:defRPr sz="900">
-                <a:solidFill>
-                  <a:srgbClr val="C9D1D9"/>
-                </a:solidFill>
-                <a:latin typeface="Consolas"/>
-              </a:defRPr>
-            </a:pPr>
-          </a:p>
-          <a:p>
-            <a:pPr>
-              <a:lnSpc>
-                <a:spcPct val="100000"/>
-              </a:lnSpc>
-              <a:spcAft>
-                <a:spcPts val="0"/>
-              </a:spcAft>
-              <a:defRPr sz="900">
-                <a:solidFill>
-                  <a:srgbClr val="C9D1D9"/>
-                </a:solidFill>
-                <a:latin typeface="Consolas"/>
-              </a:defRPr>
-            </a:pPr>
-            <a:r>
-              <a:t>   Advantages: Widely available, interpretable (charge-based)</a:t>
-            </a:r>
-          </a:p>
-          <a:p>
-            <a:pPr>
-              <a:lnSpc>
-                <a:spcPct val="100000"/>
-              </a:lnSpc>
-              <a:spcAft>
-                <a:spcPts val="0"/>
-              </a:spcAft>
-              <a:defRPr sz="900">
-                <a:solidFill>
-                  <a:srgbClr val="8B949E"/>
-                </a:solidFill>
-                <a:latin typeface="Consolas"/>
-              </a:defRPr>
-            </a:pPr>
-            <a:r>
-              <a:t>   Limitations: Indirect approach, charge assignment ambiguity</a:t>
-            </a:r>
-          </a:p>
-          <a:p>
-            <a:pPr>
-              <a:lnSpc>
-                <a:spcPct val="100000"/>
-              </a:lnSpc>
-              <a:spcAft>
-                <a:spcPts val="0"/>
-              </a:spcAft>
-              <a:defRPr sz="900">
-                <a:solidFill>
-                  <a:srgbClr val="C9D1D9"/>
-                </a:solidFill>
-                <a:latin typeface="Consolas"/>
-              </a:defRPr>
-            </a:pPr>
-          </a:p>
-          <a:p>
-            <a:pPr>
-              <a:lnSpc>
-                <a:spcPct val="100000"/>
-              </a:lnSpc>
-              <a:spcAft>
-                <a:spcPts val="0"/>
-              </a:spcAft>
-              <a:defRPr sz="900">
-                <a:solidFill>
-                  <a:srgbClr val="C9D1D9"/>
-                </a:solidFill>
-                <a:latin typeface="Consolas"/>
-              </a:defRPr>
-            </a:pPr>
-          </a:p>
-          <a:p>
-            <a:pPr>
-              <a:lnSpc>
-                <a:spcPct val="100000"/>
-              </a:lnSpc>
-              <a:spcAft>
-                <a:spcPts val="0"/>
-              </a:spcAft>
-              <a:defRPr sz="900">
-                <a:solidFill>
-                  <a:srgbClr val="BC8CFF"/>
-                </a:solidFill>
-                <a:latin typeface="Consolas"/>
-              </a:defRPr>
-            </a:pPr>
-            <a:r>
-              <a:t>FALLBACK HIERARCHY: MACE-ML → Espaloma → xTB → Geometry-based</a:t>
+              <a:t>  MACE-ML → Espaloma → xTB → Geometry</a:t>
             </a:r>
           </a:p>
         </p:txBody>
@@ -4000,7 +3547,7 @@
         </p:nvSpPr>
         <p:spPr>
           <a:xfrm>
-            <a:off x="457200" y="274320"/>
+            <a:off x="457200" y="365760"/>
             <a:ext cx="8229600" cy="457200"/>
           </a:xfrm>
           <a:prstGeom prst="rect">
@@ -4015,7 +3562,7 @@
           <a:lstStyle/>
           <a:p>
             <a:pPr>
-              <a:defRPr sz="2400" b="1">
+              <a:defRPr sz="2800" b="1">
                 <a:solidFill>
                   <a:srgbClr val="58A6FF"/>
                 </a:solidFill>
@@ -4023,7 +3570,7 @@
               </a:defRPr>
             </a:pPr>
             <a:r>
-              <a:t>$ cat eigenvector_mode_matching.txt</a:t>
+              <a:t>$ cat mode_matching.md</a:t>
             </a:r>
           </a:p>
         </p:txBody>
@@ -4036,8 +3583,8 @@
         </p:nvSpPr>
         <p:spPr>
           <a:xfrm>
-            <a:off x="457200" y="914400"/>
-            <a:ext cx="8229600" cy="5486400"/>
+            <a:off x="731520" y="1097280"/>
+            <a:ext cx="7680960" cy="4389120"/>
           </a:xfrm>
           <a:prstGeom prst="rect">
             <a:avLst/>
@@ -4055,9 +3602,9 @@
                 <a:spcPct val="100000"/>
               </a:lnSpc>
               <a:spcAft>
-                <a:spcPts val="0"/>
-              </a:spcAft>
-              <a:defRPr sz="900">
+                <a:spcPts val="600"/>
+              </a:spcAft>
+              <a:defRPr sz="1400">
                 <a:solidFill>
                   <a:srgbClr val="58A6FF"/>
                 </a:solidFill>
@@ -4065,18 +3612,34 @@
               </a:defRPr>
             </a:pPr>
             <a:r>
-              <a:t>EIGENVECTOR MODE MATCHING ALGORITHM</a:t>
-            </a:r>
-          </a:p>
-          <a:p>
-            <a:pPr>
-              <a:lnSpc>
-                <a:spcPct val="100000"/>
-              </a:lnSpc>
-              <a:spcAft>
-                <a:spcPts val="0"/>
-              </a:spcAft>
-              <a:defRPr sz="900">
+              <a:t># Problem: Frequency Order Mismatch</a:t>
+            </a:r>
+          </a:p>
+          <a:p>
+            <a:pPr>
+              <a:lnSpc>
+                <a:spcPct val="100000"/>
+              </a:lnSpc>
+              <a:spcAft>
+                <a:spcPts val="600"/>
+              </a:spcAft>
+              <a:defRPr sz="1400">
+                <a:solidFill>
+                  <a:srgbClr val="C9D1D9"/>
+                </a:solidFill>
+                <a:latin typeface="Consolas"/>
+              </a:defRPr>
+            </a:pPr>
+          </a:p>
+          <a:p>
+            <a:pPr>
+              <a:lnSpc>
+                <a:spcPct val="100000"/>
+              </a:lnSpc>
+              <a:spcAft>
+                <a:spcPts val="600"/>
+              </a:spcAft>
+              <a:defRPr sz="1400">
                 <a:solidFill>
                   <a:srgbClr val="8B949E"/>
                 </a:solidFill>
@@ -4084,18 +3647,37 @@
               </a:defRPr>
             </a:pPr>
             <a:r>
-              <a:t>═════════════════════════════════════════════════════════════════════════</a:t>
-            </a:r>
-          </a:p>
-          <a:p>
-            <a:pPr>
-              <a:lnSpc>
-                <a:spcPct val="100000"/>
-              </a:lnSpc>
-              <a:spcAft>
-                <a:spcPts val="0"/>
-              </a:spcAft>
-              <a:defRPr sz="900">
+              <a:t>  DFT:  [500, 1200, 1500, 2900, 3100] cm⁻¹</a:t>
+            </a:r>
+          </a:p>
+          <a:p>
+            <a:pPr>
+              <a:lnSpc>
+                <a:spcPct val="100000"/>
+              </a:lnSpc>
+              <a:spcAft>
+                <a:spcPts val="600"/>
+              </a:spcAft>
+              <a:defRPr sz="1400">
+                <a:solidFill>
+                  <a:srgbClr val="8B949E"/>
+                </a:solidFill>
+                <a:latin typeface="Consolas"/>
+              </a:defRPr>
+            </a:pPr>
+            <a:r>
+              <a:t>  ML:   [498, 3095, 1205, 2895, 1498] cm⁻¹</a:t>
+            </a:r>
+          </a:p>
+          <a:p>
+            <a:pPr>
+              <a:lnSpc>
+                <a:spcPct val="100000"/>
+              </a:lnSpc>
+              <a:spcAft>
+                <a:spcPts val="600"/>
+              </a:spcAft>
+              <a:defRPr sz="1400">
                 <a:solidFill>
                   <a:srgbClr val="C9D1D9"/>
                 </a:solidFill>
@@ -4109,28 +3691,95 @@
                 <a:spcPct val="100000"/>
               </a:lnSpc>
               <a:spcAft>
-                <a:spcPts val="0"/>
-              </a:spcAft>
-              <a:defRPr sz="900">
-                <a:solidFill>
-                  <a:srgbClr val="DB6D28"/>
-                </a:solidFill>
-                <a:latin typeface="Consolas"/>
-              </a:defRPr>
-            </a:pPr>
-            <a:r>
-              <a:t>PROBLEM: Frequency Ordering Mismatch</a:t>
-            </a:r>
-          </a:p>
-          <a:p>
-            <a:pPr>
-              <a:lnSpc>
-                <a:spcPct val="100000"/>
-              </a:lnSpc>
-              <a:spcAft>
-                <a:spcPts val="0"/>
-              </a:spcAft>
-              <a:defRPr sz="900">
+                <a:spcPts val="600"/>
+              </a:spcAft>
+              <a:defRPr sz="1400">
+                <a:solidFill>
+                  <a:srgbClr val="C9D1D9"/>
+                </a:solidFill>
+                <a:latin typeface="Consolas"/>
+              </a:defRPr>
+            </a:pPr>
+            <a:r>
+              <a:t>  → Cannot compare by index</a:t>
+            </a:r>
+          </a:p>
+          <a:p>
+            <a:pPr>
+              <a:lnSpc>
+                <a:spcPct val="100000"/>
+              </a:lnSpc>
+              <a:spcAft>
+                <a:spcPts val="600"/>
+              </a:spcAft>
+              <a:defRPr sz="1400">
+                <a:solidFill>
+                  <a:srgbClr val="C9D1D9"/>
+                </a:solidFill>
+                <a:latin typeface="Consolas"/>
+              </a:defRPr>
+            </a:pPr>
+          </a:p>
+          <a:p>
+            <a:pPr>
+              <a:lnSpc>
+                <a:spcPct val="100000"/>
+              </a:lnSpc>
+              <a:spcAft>
+                <a:spcPts val="600"/>
+              </a:spcAft>
+              <a:defRPr sz="1400">
+                <a:solidFill>
+                  <a:srgbClr val="C9D1D9"/>
+                </a:solidFill>
+                <a:latin typeface="Consolas"/>
+              </a:defRPr>
+            </a:pPr>
+          </a:p>
+          <a:p>
+            <a:pPr>
+              <a:lnSpc>
+                <a:spcPct val="100000"/>
+              </a:lnSpc>
+              <a:spcAft>
+                <a:spcPts val="600"/>
+              </a:spcAft>
+              <a:defRPr sz="1400">
+                <a:solidFill>
+                  <a:srgbClr val="58A6FF"/>
+                </a:solidFill>
+                <a:latin typeface="Consolas"/>
+              </a:defRPr>
+            </a:pPr>
+            <a:r>
+              <a:t># Solution: Eigenvector Dot Product</a:t>
+            </a:r>
+          </a:p>
+          <a:p>
+            <a:pPr>
+              <a:lnSpc>
+                <a:spcPct val="100000"/>
+              </a:lnSpc>
+              <a:spcAft>
+                <a:spcPts val="600"/>
+              </a:spcAft>
+              <a:defRPr sz="1400">
+                <a:solidFill>
+                  <a:srgbClr val="C9D1D9"/>
+                </a:solidFill>
+                <a:latin typeface="Consolas"/>
+              </a:defRPr>
+            </a:pPr>
+          </a:p>
+          <a:p>
+            <a:pPr>
+              <a:lnSpc>
+                <a:spcPct val="100000"/>
+              </a:lnSpc>
+              <a:spcAft>
+                <a:spcPts val="600"/>
+              </a:spcAft>
+              <a:defRPr sz="1400">
                 <a:solidFill>
                   <a:srgbClr val="8B949E"/>
                 </a:solidFill>
@@ -4138,18 +3787,18 @@
               </a:defRPr>
             </a:pPr>
             <a:r>
-              <a:t>─────────────────────────────────────</a:t>
-            </a:r>
-          </a:p>
-          <a:p>
-            <a:pPr>
-              <a:lnSpc>
-                <a:spcPct val="100000"/>
-              </a:lnSpc>
-              <a:spcAft>
-                <a:spcPts val="0"/>
-              </a:spcAft>
-              <a:defRPr sz="900">
+              <a:t>  similarity = |v_ML · v_DFT|</a:t>
+            </a:r>
+          </a:p>
+          <a:p>
+            <a:pPr>
+              <a:lnSpc>
+                <a:spcPct val="100000"/>
+              </a:lnSpc>
+              <a:spcAft>
+                <a:spcPts val="600"/>
+              </a:spcAft>
+              <a:defRPr sz="1400">
                 <a:solidFill>
                   <a:srgbClr val="C9D1D9"/>
                 </a:solidFill>
@@ -4163,9 +3812,9 @@
                 <a:spcPct val="100000"/>
               </a:lnSpc>
               <a:spcAft>
-                <a:spcPts val="0"/>
-              </a:spcAft>
-              <a:defRPr sz="900">
+                <a:spcPts val="600"/>
+              </a:spcAft>
+              <a:defRPr sz="1400">
                 <a:solidFill>
                   <a:srgbClr val="C9D1D9"/>
                 </a:solidFill>
@@ -4173,72 +3822,107 @@
               </a:defRPr>
             </a:pPr>
             <a:r>
-              <a:t>DFT and ML calculations produce vibrational frequencies in different orders:</a:t>
-            </a:r>
-          </a:p>
-          <a:p>
-            <a:pPr>
-              <a:lnSpc>
-                <a:spcPct val="100000"/>
-              </a:lnSpc>
-              <a:spcAft>
-                <a:spcPts val="0"/>
-              </a:spcAft>
-              <a:defRPr sz="900">
+              <a:t>  → Compare atomic displacement patterns</a:t>
+            </a:r>
+          </a:p>
+          <a:p>
+            <a:pPr>
+              <a:lnSpc>
+                <a:spcPct val="100000"/>
+              </a:lnSpc>
+              <a:spcAft>
+                <a:spcPts val="600"/>
+              </a:spcAft>
+              <a:defRPr sz="1400">
                 <a:solidFill>
                   <a:srgbClr val="C9D1D9"/>
                 </a:solidFill>
                 <a:latin typeface="Consolas"/>
               </a:defRPr>
             </a:pPr>
-          </a:p>
-          <a:p>
-            <a:pPr>
-              <a:lnSpc>
-                <a:spcPct val="100000"/>
-              </a:lnSpc>
-              <a:spcAft>
-                <a:spcPts val="0"/>
-              </a:spcAft>
-              <a:defRPr sz="900">
-                <a:solidFill>
-                  <a:srgbClr val="57AB5A"/>
-                </a:solidFill>
-                <a:latin typeface="Consolas"/>
-              </a:defRPr>
-            </a:pPr>
-            <a:r>
-              <a:t>  DFT Frequencies:  [500, 1200, 1500, 2900, 3100, 3200] cm⁻¹</a:t>
-            </a:r>
-          </a:p>
-          <a:p>
-            <a:pPr>
-              <a:lnSpc>
-                <a:spcPct val="100000"/>
-              </a:lnSpc>
-              <a:spcAft>
-                <a:spcPts val="0"/>
-              </a:spcAft>
-              <a:defRPr sz="900">
-                <a:solidFill>
-                  <a:srgbClr val="DB6D28"/>
-                </a:solidFill>
-                <a:latin typeface="Consolas"/>
-              </a:defRPr>
-            </a:pPr>
-            <a:r>
-              <a:t>  ML Frequencies:   [498, 3195, 1205, 2895, 1498, 3098] cm⁻¹</a:t>
-            </a:r>
-          </a:p>
-          <a:p>
-            <a:pPr>
-              <a:lnSpc>
-                <a:spcPct val="100000"/>
-              </a:lnSpc>
-              <a:spcAft>
-                <a:spcPts val="0"/>
-              </a:spcAft>
-              <a:defRPr sz="900">
+            <a:r>
+              <a:t>  → Find best match (threshold &gt; 0.8)</a:t>
+            </a:r>
+          </a:p>
+          <a:p>
+            <a:pPr>
+              <a:lnSpc>
+                <a:spcPct val="100000"/>
+              </a:lnSpc>
+              <a:spcAft>
+                <a:spcPts val="600"/>
+              </a:spcAft>
+              <a:defRPr sz="1400">
+                <a:solidFill>
+                  <a:srgbClr val="C9D1D9"/>
+                </a:solidFill>
+                <a:latin typeface="Consolas"/>
+              </a:defRPr>
+            </a:pPr>
+            <a:r>
+              <a:t>  → Robust to frequency ordering</a:t>
+            </a:r>
+          </a:p>
+          <a:p>
+            <a:pPr>
+              <a:lnSpc>
+                <a:spcPct val="100000"/>
+              </a:lnSpc>
+              <a:spcAft>
+                <a:spcPts val="600"/>
+              </a:spcAft>
+              <a:defRPr sz="1400">
+                <a:solidFill>
+                  <a:srgbClr val="C9D1D9"/>
+                </a:solidFill>
+                <a:latin typeface="Consolas"/>
+              </a:defRPr>
+            </a:pPr>
+          </a:p>
+          <a:p>
+            <a:pPr>
+              <a:lnSpc>
+                <a:spcPct val="100000"/>
+              </a:lnSpc>
+              <a:spcAft>
+                <a:spcPts val="600"/>
+              </a:spcAft>
+              <a:defRPr sz="1400">
+                <a:solidFill>
+                  <a:srgbClr val="C9D1D9"/>
+                </a:solidFill>
+                <a:latin typeface="Consolas"/>
+              </a:defRPr>
+            </a:pPr>
+          </a:p>
+          <a:p>
+            <a:pPr>
+              <a:lnSpc>
+                <a:spcPct val="100000"/>
+              </a:lnSpc>
+              <a:spcAft>
+                <a:spcPts val="600"/>
+              </a:spcAft>
+              <a:defRPr sz="1400">
+                <a:solidFill>
+                  <a:srgbClr val="58A6FF"/>
+                </a:solidFill>
+                <a:latin typeface="Consolas"/>
+              </a:defRPr>
+            </a:pPr>
+            <a:r>
+              <a:t># Example</a:t>
+            </a:r>
+          </a:p>
+          <a:p>
+            <a:pPr>
+              <a:lnSpc>
+                <a:spcPct val="100000"/>
+              </a:lnSpc>
+              <a:spcAft>
+                <a:spcPts val="600"/>
+              </a:spcAft>
+              <a:defRPr sz="1400">
                 <a:solidFill>
                   <a:srgbClr val="8B949E"/>
                 </a:solidFill>
@@ -4246,18 +3930,18 @@
               </a:defRPr>
             </a:pPr>
             <a:r>
-              <a:t>                     ↑    ↑     ↑     ↑     ↑     ↑</a:t>
-            </a:r>
-          </a:p>
-          <a:p>
-            <a:pPr>
-              <a:lnSpc>
-                <a:spcPct val="100000"/>
-              </a:lnSpc>
-              <a:spcAft>
-                <a:spcPts val="0"/>
-              </a:spcAft>
-              <a:defRPr sz="900">
+              <a:t>  ML 498 cm⁻¹ → DFT 500 cm⁻¹  [0.996]</a:t>
+            </a:r>
+          </a:p>
+          <a:p>
+            <a:pPr>
+              <a:lnSpc>
+                <a:spcPct val="100000"/>
+              </a:lnSpc>
+              <a:spcAft>
+                <a:spcPts val="600"/>
+              </a:spcAft>
+              <a:defRPr sz="1400">
                 <a:solidFill>
                   <a:srgbClr val="8B949E"/>
                 </a:solidFill>
@@ -4265,667 +3949,7 @@
               </a:defRPr>
             </a:pPr>
             <a:r>
-              <a:t>  Cannot directly compare by index!</a:t>
-            </a:r>
-          </a:p>
-          <a:p>
-            <a:pPr>
-              <a:lnSpc>
-                <a:spcPct val="100000"/>
-              </a:lnSpc>
-              <a:spcAft>
-                <a:spcPts val="0"/>
-              </a:spcAft>
-              <a:defRPr sz="900">
-                <a:solidFill>
-                  <a:srgbClr val="C9D1D9"/>
-                </a:solidFill>
-                <a:latin typeface="Consolas"/>
-              </a:defRPr>
-            </a:pPr>
-          </a:p>
-          <a:p>
-            <a:pPr>
-              <a:lnSpc>
-                <a:spcPct val="100000"/>
-              </a:lnSpc>
-              <a:spcAft>
-                <a:spcPts val="0"/>
-              </a:spcAft>
-              <a:defRPr sz="900">
-                <a:solidFill>
-                  <a:srgbClr val="C9D1D9"/>
-                </a:solidFill>
-                <a:latin typeface="Consolas"/>
-              </a:defRPr>
-            </a:pPr>
-          </a:p>
-          <a:p>
-            <a:pPr>
-              <a:lnSpc>
-                <a:spcPct val="100000"/>
-              </a:lnSpc>
-              <a:spcAft>
-                <a:spcPts val="0"/>
-              </a:spcAft>
-              <a:defRPr sz="900">
-                <a:solidFill>
-                  <a:srgbClr val="58A6FF"/>
-                </a:solidFill>
-                <a:latin typeface="Consolas"/>
-              </a:defRPr>
-            </a:pPr>
-            <a:r>
-              <a:t>SOLUTION: Eigenvector Dot Product Matching</a:t>
-            </a:r>
-          </a:p>
-          <a:p>
-            <a:pPr>
-              <a:lnSpc>
-                <a:spcPct val="100000"/>
-              </a:lnSpc>
-              <a:spcAft>
-                <a:spcPts val="0"/>
-              </a:spcAft>
-              <a:defRPr sz="900">
-                <a:solidFill>
-                  <a:srgbClr val="8B949E"/>
-                </a:solidFill>
-                <a:latin typeface="Consolas"/>
-              </a:defRPr>
-            </a:pPr>
-            <a:r>
-              <a:t>───────────────────────────────────────────</a:t>
-            </a:r>
-          </a:p>
-          <a:p>
-            <a:pPr>
-              <a:lnSpc>
-                <a:spcPct val="100000"/>
-              </a:lnSpc>
-              <a:spcAft>
-                <a:spcPts val="0"/>
-              </a:spcAft>
-              <a:defRPr sz="900">
-                <a:solidFill>
-                  <a:srgbClr val="C9D1D9"/>
-                </a:solidFill>
-                <a:latin typeface="Consolas"/>
-              </a:defRPr>
-            </a:pPr>
-          </a:p>
-          <a:p>
-            <a:pPr>
-              <a:lnSpc>
-                <a:spcPct val="100000"/>
-              </a:lnSpc>
-              <a:spcAft>
-                <a:spcPts val="0"/>
-              </a:spcAft>
-              <a:defRPr sz="900">
-                <a:solidFill>
-                  <a:srgbClr val="C9D1D9"/>
-                </a:solidFill>
-                <a:latin typeface="Consolas"/>
-              </a:defRPr>
-            </a:pPr>
-            <a:r>
-              <a:t>Each vibrational mode has an eigenvector describing atomic displacements:</a:t>
-            </a:r>
-          </a:p>
-          <a:p>
-            <a:pPr>
-              <a:lnSpc>
-                <a:spcPct val="100000"/>
-              </a:lnSpc>
-              <a:spcAft>
-                <a:spcPts val="0"/>
-              </a:spcAft>
-              <a:defRPr sz="900">
-                <a:solidFill>
-                  <a:srgbClr val="C9D1D9"/>
-                </a:solidFill>
-                <a:latin typeface="Consolas"/>
-              </a:defRPr>
-            </a:pPr>
-          </a:p>
-          <a:p>
-            <a:pPr>
-              <a:lnSpc>
-                <a:spcPct val="100000"/>
-              </a:lnSpc>
-              <a:spcAft>
-                <a:spcPts val="0"/>
-              </a:spcAft>
-              <a:defRPr sz="900">
-                <a:solidFill>
-                  <a:srgbClr val="58A6FF"/>
-                </a:solidFill>
-                <a:latin typeface="Consolas"/>
-              </a:defRPr>
-            </a:pPr>
-            <a:r>
-              <a:t>┌────────────────────────────────────────────────────────────────────────┐</a:t>
-            </a:r>
-          </a:p>
-          <a:p>
-            <a:pPr>
-              <a:lnSpc>
-                <a:spcPct val="100000"/>
-              </a:lnSpc>
-              <a:spcAft>
-                <a:spcPts val="0"/>
-              </a:spcAft>
-              <a:defRPr sz="900">
-                <a:solidFill>
-                  <a:srgbClr val="C9D1D9"/>
-                </a:solidFill>
-                <a:latin typeface="Consolas"/>
-              </a:defRPr>
-            </a:pPr>
-            <a:r>
-              <a:t>│  For each ML mode i:                                                   │</a:t>
-            </a:r>
-          </a:p>
-          <a:p>
-            <a:pPr>
-              <a:lnSpc>
-                <a:spcPct val="100000"/>
-              </a:lnSpc>
-              <a:spcAft>
-                <a:spcPts val="0"/>
-              </a:spcAft>
-              <a:defRPr sz="900">
-                <a:solidFill>
-                  <a:srgbClr val="C9D1D9"/>
-                </a:solidFill>
-                <a:latin typeface="Consolas"/>
-              </a:defRPr>
-            </a:pPr>
-            <a:r>
-              <a:t>│                                                                         │</a:t>
-            </a:r>
-          </a:p>
-          <a:p>
-            <a:pPr>
-              <a:lnSpc>
-                <a:spcPct val="100000"/>
-              </a:lnSpc>
-              <a:spcAft>
-                <a:spcPts val="0"/>
-              </a:spcAft>
-              <a:defRPr sz="900">
-                <a:solidFill>
-                  <a:srgbClr val="C9D1D9"/>
-                </a:solidFill>
-                <a:latin typeface="Consolas"/>
-              </a:defRPr>
-            </a:pPr>
-            <a:r>
-              <a:t>│    1. Calculate dot product with all DFT modes:                        │</a:t>
-            </a:r>
-          </a:p>
-          <a:p>
-            <a:pPr>
-              <a:lnSpc>
-                <a:spcPct val="100000"/>
-              </a:lnSpc>
-              <a:spcAft>
-                <a:spcPts val="0"/>
-              </a:spcAft>
-              <a:defRPr sz="900">
-                <a:solidFill>
-                  <a:srgbClr val="C9D1D9"/>
-                </a:solidFill>
-                <a:latin typeface="Consolas"/>
-              </a:defRPr>
-            </a:pPr>
-            <a:r>
-              <a:t>│                                                                         │</a:t>
-            </a:r>
-          </a:p>
-          <a:p>
-            <a:pPr>
-              <a:lnSpc>
-                <a:spcPct val="100000"/>
-              </a:lnSpc>
-              <a:spcAft>
-                <a:spcPts val="0"/>
-              </a:spcAft>
-              <a:defRPr sz="900">
-                <a:solidFill>
-                  <a:srgbClr val="57AB5A"/>
-                </a:solidFill>
-                <a:latin typeface="Consolas"/>
-              </a:defRPr>
-            </a:pPr>
-            <a:r>
-              <a:t>│       similarity[j] = |v_ML[i] · v_DFT[j]|                             │</a:t>
-            </a:r>
-          </a:p>
-          <a:p>
-            <a:pPr>
-              <a:lnSpc>
-                <a:spcPct val="100000"/>
-              </a:lnSpc>
-              <a:spcAft>
-                <a:spcPts val="0"/>
-              </a:spcAft>
-              <a:defRPr sz="900">
-                <a:solidFill>
-                  <a:srgbClr val="C9D1D9"/>
-                </a:solidFill>
-                <a:latin typeface="Consolas"/>
-              </a:defRPr>
-            </a:pPr>
-            <a:r>
-              <a:t>│                                                                         │</a:t>
-            </a:r>
-          </a:p>
-          <a:p>
-            <a:pPr>
-              <a:lnSpc>
-                <a:spcPct val="100000"/>
-              </a:lnSpc>
-              <a:spcAft>
-                <a:spcPts val="0"/>
-              </a:spcAft>
-              <a:defRPr sz="900">
-                <a:solidFill>
-                  <a:srgbClr val="8B949E"/>
-                </a:solidFill>
-                <a:latin typeface="Consolas"/>
-              </a:defRPr>
-            </a:pPr>
-            <a:r>
-              <a:t>│       where v_ML[i], v_DFT[j] are normalized eigenvectors              │</a:t>
-            </a:r>
-          </a:p>
-          <a:p>
-            <a:pPr>
-              <a:lnSpc>
-                <a:spcPct val="100000"/>
-              </a:lnSpc>
-              <a:spcAft>
-                <a:spcPts val="0"/>
-              </a:spcAft>
-              <a:defRPr sz="900">
-                <a:solidFill>
-                  <a:srgbClr val="C9D1D9"/>
-                </a:solidFill>
-                <a:latin typeface="Consolas"/>
-              </a:defRPr>
-            </a:pPr>
-            <a:r>
-              <a:t>│                                                                         │</a:t>
-            </a:r>
-          </a:p>
-          <a:p>
-            <a:pPr>
-              <a:lnSpc>
-                <a:spcPct val="100000"/>
-              </a:lnSpc>
-              <a:spcAft>
-                <a:spcPts val="0"/>
-              </a:spcAft>
-              <a:defRPr sz="900">
-                <a:solidFill>
-                  <a:srgbClr val="C9D1D9"/>
-                </a:solidFill>
-                <a:latin typeface="Consolas"/>
-              </a:defRPr>
-            </a:pPr>
-            <a:r>
-              <a:t>│    2. Find best match:                                                 │</a:t>
-            </a:r>
-          </a:p>
-          <a:p>
-            <a:pPr>
-              <a:lnSpc>
-                <a:spcPct val="100000"/>
-              </a:lnSpc>
-              <a:spcAft>
-                <a:spcPts val="0"/>
-              </a:spcAft>
-              <a:defRPr sz="900">
-                <a:solidFill>
-                  <a:srgbClr val="C9D1D9"/>
-                </a:solidFill>
-                <a:latin typeface="Consolas"/>
-              </a:defRPr>
-            </a:pPr>
-            <a:r>
-              <a:t>│                                                                         │</a:t>
-            </a:r>
-          </a:p>
-          <a:p>
-            <a:pPr>
-              <a:lnSpc>
-                <a:spcPct val="100000"/>
-              </a:lnSpc>
-              <a:spcAft>
-                <a:spcPts val="0"/>
-              </a:spcAft>
-              <a:defRPr sz="900">
-                <a:solidFill>
-                  <a:srgbClr val="57AB5A"/>
-                </a:solidFill>
-                <a:latin typeface="Consolas"/>
-              </a:defRPr>
-            </a:pPr>
-            <a:r>
-              <a:t>│       matched_mode[i] = argmax similarity[j]                           │</a:t>
-            </a:r>
-          </a:p>
-          <a:p>
-            <a:pPr>
-              <a:lnSpc>
-                <a:spcPct val="100000"/>
-              </a:lnSpc>
-              <a:spcAft>
-                <a:spcPts val="0"/>
-              </a:spcAft>
-              <a:defRPr sz="900">
-                <a:solidFill>
-                  <a:srgbClr val="C9D1D9"/>
-                </a:solidFill>
-                <a:latin typeface="Consolas"/>
-              </a:defRPr>
-            </a:pPr>
-            <a:r>
-              <a:t>│                              j                                          │</a:t>
-            </a:r>
-          </a:p>
-          <a:p>
-            <a:pPr>
-              <a:lnSpc>
-                <a:spcPct val="100000"/>
-              </a:lnSpc>
-              <a:spcAft>
-                <a:spcPts val="0"/>
-              </a:spcAft>
-              <a:defRPr sz="900">
-                <a:solidFill>
-                  <a:srgbClr val="C9D1D9"/>
-                </a:solidFill>
-                <a:latin typeface="Consolas"/>
-              </a:defRPr>
-            </a:pPr>
-            <a:r>
-              <a:t>│                                                                         │</a:t>
-            </a:r>
-          </a:p>
-          <a:p>
-            <a:pPr>
-              <a:lnSpc>
-                <a:spcPct val="100000"/>
-              </a:lnSpc>
-              <a:spcAft>
-                <a:spcPts val="0"/>
-              </a:spcAft>
-              <a:defRPr sz="900">
-                <a:solidFill>
-                  <a:srgbClr val="C9D1D9"/>
-                </a:solidFill>
-                <a:latin typeface="Consolas"/>
-              </a:defRPr>
-            </a:pPr>
-            <a:r>
-              <a:t>│    3. If similarity &gt; threshold (0.8):                                 │</a:t>
-            </a:r>
-          </a:p>
-          <a:p>
-            <a:pPr>
-              <a:lnSpc>
-                <a:spcPct val="100000"/>
-              </a:lnSpc>
-              <a:spcAft>
-                <a:spcPts val="0"/>
-              </a:spcAft>
-              <a:defRPr sz="900">
-                <a:solidFill>
-                  <a:srgbClr val="C9D1D9"/>
-                </a:solidFill>
-                <a:latin typeface="Consolas"/>
-              </a:defRPr>
-            </a:pPr>
-            <a:r>
-              <a:t>│       → Match confirmed, compare frequencies                           │</a:t>
-            </a:r>
-          </a:p>
-          <a:p>
-            <a:pPr>
-              <a:lnSpc>
-                <a:spcPct val="100000"/>
-              </a:lnSpc>
-              <a:spcAft>
-                <a:spcPts val="0"/>
-              </a:spcAft>
-              <a:defRPr sz="900">
-                <a:solidFill>
-                  <a:srgbClr val="C9D1D9"/>
-                </a:solidFill>
-                <a:latin typeface="Consolas"/>
-              </a:defRPr>
-            </a:pPr>
-            <a:r>
-              <a:t>│       Else:                                                            │</a:t>
-            </a:r>
-          </a:p>
-          <a:p>
-            <a:pPr>
-              <a:lnSpc>
-                <a:spcPct val="100000"/>
-              </a:lnSpc>
-              <a:spcAft>
-                <a:spcPts val="0"/>
-              </a:spcAft>
-              <a:defRPr sz="900">
-                <a:solidFill>
-                  <a:srgbClr val="C9D1D9"/>
-                </a:solidFill>
-                <a:latin typeface="Consolas"/>
-              </a:defRPr>
-            </a:pPr>
-            <a:r>
-              <a:t>│       → Mode not found in DFT calculation                              │</a:t>
-            </a:r>
-          </a:p>
-          <a:p>
-            <a:pPr>
-              <a:lnSpc>
-                <a:spcPct val="100000"/>
-              </a:lnSpc>
-              <a:spcAft>
-                <a:spcPts val="0"/>
-              </a:spcAft>
-              <a:defRPr sz="900">
-                <a:solidFill>
-                  <a:srgbClr val="58A6FF"/>
-                </a:solidFill>
-                <a:latin typeface="Consolas"/>
-              </a:defRPr>
-            </a:pPr>
-            <a:r>
-              <a:t>└────────────────────────────────────────────────────────────────────────┘</a:t>
-            </a:r>
-          </a:p>
-          <a:p>
-            <a:pPr>
-              <a:lnSpc>
-                <a:spcPct val="100000"/>
-              </a:lnSpc>
-              <a:spcAft>
-                <a:spcPts val="0"/>
-              </a:spcAft>
-              <a:defRPr sz="900">
-                <a:solidFill>
-                  <a:srgbClr val="C9D1D9"/>
-                </a:solidFill>
-                <a:latin typeface="Consolas"/>
-              </a:defRPr>
-            </a:pPr>
-          </a:p>
-          <a:p>
-            <a:pPr>
-              <a:lnSpc>
-                <a:spcPct val="100000"/>
-              </a:lnSpc>
-              <a:spcAft>
-                <a:spcPts val="0"/>
-              </a:spcAft>
-              <a:defRPr sz="900">
-                <a:solidFill>
-                  <a:srgbClr val="C9D1D9"/>
-                </a:solidFill>
-                <a:latin typeface="Consolas"/>
-              </a:defRPr>
-            </a:pPr>
-          </a:p>
-          <a:p>
-            <a:pPr>
-              <a:lnSpc>
-                <a:spcPct val="100000"/>
-              </a:lnSpc>
-              <a:spcAft>
-                <a:spcPts val="0"/>
-              </a:spcAft>
-              <a:defRPr sz="900">
-                <a:solidFill>
-                  <a:srgbClr val="DB6D28"/>
-                </a:solidFill>
-                <a:latin typeface="Consolas"/>
-              </a:defRPr>
-            </a:pPr>
-            <a:r>
-              <a:t>EXAMPLE MATCHING:</a:t>
-            </a:r>
-          </a:p>
-          <a:p>
-            <a:pPr>
-              <a:lnSpc>
-                <a:spcPct val="100000"/>
-              </a:lnSpc>
-              <a:spcAft>
-                <a:spcPts val="0"/>
-              </a:spcAft>
-              <a:defRPr sz="900">
-                <a:solidFill>
-                  <a:srgbClr val="C9D1D9"/>
-                </a:solidFill>
-                <a:latin typeface="Consolas"/>
-              </a:defRPr>
-            </a:pPr>
-          </a:p>
-          <a:p>
-            <a:pPr>
-              <a:lnSpc>
-                <a:spcPct val="100000"/>
-              </a:lnSpc>
-              <a:spcAft>
-                <a:spcPts val="0"/>
-              </a:spcAft>
-              <a:defRPr sz="900">
-                <a:solidFill>
-                  <a:srgbClr val="C9D1D9"/>
-                </a:solidFill>
-                <a:latin typeface="Consolas"/>
-              </a:defRPr>
-            </a:pPr>
-            <a:r>
-              <a:t>  ML Mode 1 (498 cm⁻¹)  → DFT Mode 1 (500 cm⁻¹)   [dot product: 0.996]</a:t>
-            </a:r>
-          </a:p>
-          <a:p>
-            <a:pPr>
-              <a:lnSpc>
-                <a:spcPct val="100000"/>
-              </a:lnSpc>
-              <a:spcAft>
-                <a:spcPts val="0"/>
-              </a:spcAft>
-              <a:defRPr sz="900">
-                <a:solidFill>
-                  <a:srgbClr val="C9D1D9"/>
-                </a:solidFill>
-                <a:latin typeface="Consolas"/>
-              </a:defRPr>
-            </a:pPr>
-            <a:r>
-              <a:t>  ML Mode 2 (3195 cm⁻¹) → DFT Mode 6 (3200 cm⁻¹)  [dot product: 0.989]</a:t>
-            </a:r>
-          </a:p>
-          <a:p>
-            <a:pPr>
-              <a:lnSpc>
-                <a:spcPct val="100000"/>
-              </a:lnSpc>
-              <a:spcAft>
-                <a:spcPts val="0"/>
-              </a:spcAft>
-              <a:defRPr sz="900">
-                <a:solidFill>
-                  <a:srgbClr val="C9D1D9"/>
-                </a:solidFill>
-                <a:latin typeface="Consolas"/>
-              </a:defRPr>
-            </a:pPr>
-            <a:r>
-              <a:t>  ML Mode 3 (1205 cm⁻¹) → DFT Mode 2 (1200 cm⁻¹)  [dot product: 0.993]</a:t>
-            </a:r>
-          </a:p>
-          <a:p>
-            <a:pPr>
-              <a:lnSpc>
-                <a:spcPct val="100000"/>
-              </a:lnSpc>
-              <a:spcAft>
-                <a:spcPts val="0"/>
-              </a:spcAft>
-              <a:defRPr sz="900">
-                <a:solidFill>
-                  <a:srgbClr val="8B949E"/>
-                </a:solidFill>
-                <a:latin typeface="Consolas"/>
-              </a:defRPr>
-            </a:pPr>
-            <a:r>
-              <a:t>  ...</a:t>
-            </a:r>
-          </a:p>
-          <a:p>
-            <a:pPr>
-              <a:lnSpc>
-                <a:spcPct val="100000"/>
-              </a:lnSpc>
-              <a:spcAft>
-                <a:spcPts val="0"/>
-              </a:spcAft>
-              <a:defRPr sz="900">
-                <a:solidFill>
-                  <a:srgbClr val="C9D1D9"/>
-                </a:solidFill>
-                <a:latin typeface="Consolas"/>
-              </a:defRPr>
-            </a:pPr>
-          </a:p>
-          <a:p>
-            <a:pPr>
-              <a:lnSpc>
-                <a:spcPct val="100000"/>
-              </a:lnSpc>
-              <a:spcAft>
-                <a:spcPts val="0"/>
-              </a:spcAft>
-              <a:defRPr sz="900">
-                <a:solidFill>
-                  <a:srgbClr val="BC8CFF"/>
-                </a:solidFill>
-                <a:latin typeface="Consolas"/>
-              </a:defRPr>
-            </a:pPr>
-            <a:r>
-              <a:t>Implementation: gaussian_parser.py, analyze_spectra.py</a:t>
+              <a:t>  ML 3095 cm⁻¹ → DFT 3100 cm⁻¹ [0.989]</a:t>
             </a:r>
           </a:p>
         </p:txBody>
@@ -4964,7 +3988,7 @@
         </p:nvSpPr>
         <p:spPr>
           <a:xfrm>
-            <a:off x="457200" y="274320"/>
+            <a:off x="457200" y="365760"/>
             <a:ext cx="8229600" cy="457200"/>
           </a:xfrm>
           <a:prstGeom prst="rect">
@@ -4979,7 +4003,7 @@
           <a:lstStyle/>
           <a:p>
             <a:pPr>
-              <a:defRPr sz="2400" b="1">
+              <a:defRPr sz="2800" b="1">
                 <a:solidFill>
                   <a:srgbClr val="58A6FF"/>
                 </a:solidFill>
@@ -4987,7 +4011,7 @@
               </a:defRPr>
             </a:pPr>
             <a:r>
-              <a:t>$ cat output_file_parsing.txt</a:t>
+              <a:t>$ ls -la parsing/</a:t>
             </a:r>
           </a:p>
         </p:txBody>
@@ -5000,8 +4024,8 @@
         </p:nvSpPr>
         <p:spPr>
           <a:xfrm>
-            <a:off x="457200" y="914400"/>
-            <a:ext cx="8229600" cy="5486400"/>
+            <a:off x="731520" y="1097280"/>
+            <a:ext cx="7680960" cy="4389120"/>
           </a:xfrm>
           <a:prstGeom prst="rect">
             <a:avLst/>
@@ -5019,9 +4043,9 @@
                 <a:spcPct val="100000"/>
               </a:lnSpc>
               <a:spcAft>
-                <a:spcPts val="0"/>
-              </a:spcAft>
-              <a:defRPr sz="800">
+                <a:spcPts val="600"/>
+              </a:spcAft>
+              <a:defRPr sz="1400">
                 <a:solidFill>
                   <a:srgbClr val="58A6FF"/>
                 </a:solidFill>
@@ -5029,18 +4053,145 @@
               </a:defRPr>
             </a:pPr>
             <a:r>
-              <a:t>OUTPUT FILE PARSING REQUIREMENTS</a:t>
-            </a:r>
-          </a:p>
-          <a:p>
-            <a:pPr>
-              <a:lnSpc>
-                <a:spcPct val="100000"/>
-              </a:lnSpc>
-              <a:spcAft>
-                <a:spcPts val="0"/>
-              </a:spcAft>
-              <a:defRPr sz="800">
+              <a:t># Gaussian .log Files (2-10 MB)</a:t>
+            </a:r>
+          </a:p>
+          <a:p>
+            <a:pPr>
+              <a:lnSpc>
+                <a:spcPct val="100000"/>
+              </a:lnSpc>
+              <a:spcAft>
+                <a:spcPts val="600"/>
+              </a:spcAft>
+              <a:defRPr sz="1400">
+                <a:solidFill>
+                  <a:srgbClr val="C9D1D9"/>
+                </a:solidFill>
+                <a:latin typeface="Consolas"/>
+              </a:defRPr>
+            </a:pPr>
+          </a:p>
+          <a:p>
+            <a:pPr>
+              <a:lnSpc>
+                <a:spcPct val="100000"/>
+              </a:lnSpc>
+              <a:spcAft>
+                <a:spcPts val="600"/>
+              </a:spcAft>
+              <a:defRPr sz="1400">
+                <a:solidFill>
+                  <a:srgbClr val="C9D1D9"/>
+                </a:solidFill>
+                <a:latin typeface="Consolas"/>
+              </a:defRPr>
+            </a:pPr>
+            <a:r>
+              <a:t>  → Harmonic frequencies</a:t>
+            </a:r>
+          </a:p>
+          <a:p>
+            <a:pPr>
+              <a:lnSpc>
+                <a:spcPct val="100000"/>
+              </a:lnSpc>
+              <a:spcAft>
+                <a:spcPts val="600"/>
+              </a:spcAft>
+              <a:defRPr sz="1400">
+                <a:solidFill>
+                  <a:srgbClr val="C9D1D9"/>
+                </a:solidFill>
+                <a:latin typeface="Consolas"/>
+              </a:defRPr>
+            </a:pPr>
+            <a:r>
+              <a:t>  → Anharmonic frequencies</a:t>
+            </a:r>
+          </a:p>
+          <a:p>
+            <a:pPr>
+              <a:lnSpc>
+                <a:spcPct val="100000"/>
+              </a:lnSpc>
+              <a:spcAft>
+                <a:spcPts val="600"/>
+              </a:spcAft>
+              <a:defRPr sz="1400">
+                <a:solidFill>
+                  <a:srgbClr val="C9D1D9"/>
+                </a:solidFill>
+                <a:latin typeface="Consolas"/>
+              </a:defRPr>
+            </a:pPr>
+            <a:r>
+              <a:t>  → Overtones &amp; combination bands</a:t>
+            </a:r>
+          </a:p>
+          <a:p>
+            <a:pPr>
+              <a:lnSpc>
+                <a:spcPct val="100000"/>
+              </a:lnSpc>
+              <a:spcAft>
+                <a:spcPts val="600"/>
+              </a:spcAft>
+              <a:defRPr sz="1400">
+                <a:solidFill>
+                  <a:srgbClr val="C9D1D9"/>
+                </a:solidFill>
+                <a:latin typeface="Consolas"/>
+              </a:defRPr>
+            </a:pPr>
+            <a:r>
+              <a:t>  → IR intensities</a:t>
+            </a:r>
+          </a:p>
+          <a:p>
+            <a:pPr>
+              <a:lnSpc>
+                <a:spcPct val="100000"/>
+              </a:lnSpc>
+              <a:spcAft>
+                <a:spcPts val="600"/>
+              </a:spcAft>
+              <a:defRPr sz="1400">
+                <a:solidFill>
+                  <a:srgbClr val="C9D1D9"/>
+                </a:solidFill>
+                <a:latin typeface="Consolas"/>
+              </a:defRPr>
+            </a:pPr>
+            <a:r>
+              <a:t>  → Eigenvectors (3N-6 modes)</a:t>
+            </a:r>
+          </a:p>
+          <a:p>
+            <a:pPr>
+              <a:lnSpc>
+                <a:spcPct val="100000"/>
+              </a:lnSpc>
+              <a:spcAft>
+                <a:spcPts val="600"/>
+              </a:spcAft>
+              <a:defRPr sz="1400">
+                <a:solidFill>
+                  <a:srgbClr val="C9D1D9"/>
+                </a:solidFill>
+                <a:latin typeface="Consolas"/>
+              </a:defRPr>
+            </a:pPr>
+          </a:p>
+          <a:p>
+            <a:pPr>
+              <a:lnSpc>
+                <a:spcPct val="100000"/>
+              </a:lnSpc>
+              <a:spcAft>
+                <a:spcPts val="600"/>
+              </a:spcAft>
+              <a:defRPr sz="1400">
                 <a:solidFill>
                   <a:srgbClr val="8B949E"/>
                 </a:solidFill>
@@ -5048,69 +4199,107 @@
               </a:defRPr>
             </a:pPr>
             <a:r>
-              <a:t>═════════════════════════════════════════════════════════════════════════</a:t>
-            </a:r>
-          </a:p>
-          <a:p>
-            <a:pPr>
-              <a:lnSpc>
-                <a:spcPct val="100000"/>
-              </a:lnSpc>
-              <a:spcAft>
-                <a:spcPts val="0"/>
-              </a:spcAft>
-              <a:defRPr sz="800">
+              <a:t>  Challenges:</a:t>
+            </a:r>
+          </a:p>
+          <a:p>
+            <a:pPr>
+              <a:lnSpc>
+                <a:spcPct val="100000"/>
+              </a:lnSpc>
+              <a:spcAft>
+                <a:spcPts val="600"/>
+              </a:spcAft>
+              <a:defRPr sz="1400">
                 <a:solidFill>
                   <a:srgbClr val="C9D1D9"/>
                 </a:solidFill>
                 <a:latin typeface="Consolas"/>
               </a:defRPr>
             </a:pPr>
-          </a:p>
-          <a:p>
-            <a:pPr>
-              <a:lnSpc>
-                <a:spcPct val="100000"/>
-              </a:lnSpc>
-              <a:spcAft>
-                <a:spcPts val="0"/>
-              </a:spcAft>
-              <a:defRPr sz="800">
-                <a:solidFill>
-                  <a:srgbClr val="DB6D28"/>
-                </a:solidFill>
-                <a:latin typeface="Consolas"/>
-              </a:defRPr>
-            </a:pPr>
-            <a:r>
-              <a:t>MULTIPLE FILE FORMATS TO PARSE:</a:t>
-            </a:r>
-          </a:p>
-          <a:p>
-            <a:pPr>
-              <a:lnSpc>
-                <a:spcPct val="100000"/>
-              </a:lnSpc>
-              <a:spcAft>
-                <a:spcPts val="0"/>
-              </a:spcAft>
-              <a:defRPr sz="800">
+            <a:r>
+              <a:t>  • Multi-column format (3 modes/block)</a:t>
+            </a:r>
+          </a:p>
+          <a:p>
+            <a:pPr>
+              <a:lnSpc>
+                <a:spcPct val="100000"/>
+              </a:lnSpc>
+              <a:spcAft>
+                <a:spcPts val="600"/>
+              </a:spcAft>
+              <a:defRPr sz="1400">
                 <a:solidFill>
                   <a:srgbClr val="C9D1D9"/>
                 </a:solidFill>
                 <a:latin typeface="Consolas"/>
               </a:defRPr>
             </a:pPr>
-          </a:p>
-          <a:p>
-            <a:pPr>
-              <a:lnSpc>
-                <a:spcPct val="100000"/>
-              </a:lnSpc>
-              <a:spcAft>
-                <a:spcPts val="0"/>
-              </a:spcAft>
-              <a:defRPr sz="800">
+            <a:r>
+              <a:t>  • 10,000-50,000 lines to search</a:t>
+            </a:r>
+          </a:p>
+          <a:p>
+            <a:pPr>
+              <a:lnSpc>
+                <a:spcPct val="100000"/>
+              </a:lnSpc>
+              <a:spcAft>
+                <a:spcPts val="600"/>
+              </a:spcAft>
+              <a:defRPr sz="1400">
+                <a:solidFill>
+                  <a:srgbClr val="C9D1D9"/>
+                </a:solidFill>
+                <a:latin typeface="Consolas"/>
+              </a:defRPr>
+            </a:pPr>
+            <a:r>
+              <a:t>  • Regex pattern matching required</a:t>
+            </a:r>
+          </a:p>
+          <a:p>
+            <a:pPr>
+              <a:lnSpc>
+                <a:spcPct val="100000"/>
+              </a:lnSpc>
+              <a:spcAft>
+                <a:spcPts val="600"/>
+              </a:spcAft>
+              <a:defRPr sz="1400">
+                <a:solidFill>
+                  <a:srgbClr val="C9D1D9"/>
+                </a:solidFill>
+                <a:latin typeface="Consolas"/>
+              </a:defRPr>
+            </a:pPr>
+          </a:p>
+          <a:p>
+            <a:pPr>
+              <a:lnSpc>
+                <a:spcPct val="100000"/>
+              </a:lnSpc>
+              <a:spcAft>
+                <a:spcPts val="600"/>
+              </a:spcAft>
+              <a:defRPr sz="1400">
+                <a:solidFill>
+                  <a:srgbClr val="C9D1D9"/>
+                </a:solidFill>
+                <a:latin typeface="Consolas"/>
+              </a:defRPr>
+            </a:pPr>
+          </a:p>
+          <a:p>
+            <a:pPr>
+              <a:lnSpc>
+                <a:spcPct val="100000"/>
+              </a:lnSpc>
+              <a:spcAft>
+                <a:spcPts val="600"/>
+              </a:spcAft>
+              <a:defRPr sz="1400">
                 <a:solidFill>
                   <a:srgbClr val="58A6FF"/>
                 </a:solidFill>
@@ -5118,18 +4307,34 @@
               </a:defRPr>
             </a:pPr>
             <a:r>
-              <a:t>1. GAUSSIAN OUTPUT FILES (.log)</a:t>
-            </a:r>
-          </a:p>
-          <a:p>
-            <a:pPr>
-              <a:lnSpc>
-                <a:spcPct val="100000"/>
-              </a:lnSpc>
-              <a:spcAft>
-                <a:spcPts val="0"/>
-              </a:spcAft>
-              <a:defRPr sz="800">
+              <a:t># JSON Results (ML)</a:t>
+            </a:r>
+          </a:p>
+          <a:p>
+            <a:pPr>
+              <a:lnSpc>
+                <a:spcPct val="100000"/>
+              </a:lnSpc>
+              <a:spcAft>
+                <a:spcPts val="600"/>
+              </a:spcAft>
+              <a:defRPr sz="1400">
+                <a:solidFill>
+                  <a:srgbClr val="C9D1D9"/>
+                </a:solidFill>
+                <a:latin typeface="Consolas"/>
+              </a:defRPr>
+            </a:pPr>
+          </a:p>
+          <a:p>
+            <a:pPr>
+              <a:lnSpc>
+                <a:spcPct val="100000"/>
+              </a:lnSpc>
+              <a:spcAft>
+                <a:spcPts val="600"/>
+              </a:spcAft>
+              <a:defRPr sz="1400">
                 <a:solidFill>
                   <a:srgbClr val="8B949E"/>
                 </a:solidFill>
@@ -5137,1107 +4342,118 @@
               </a:defRPr>
             </a:pPr>
             <a:r>
-              <a:t>   ─────────────────────────────</a:t>
-            </a:r>
-          </a:p>
-          <a:p>
-            <a:pPr>
-              <a:lnSpc>
-                <a:spcPct val="100000"/>
-              </a:lnSpc>
-              <a:spcAft>
-                <a:spcPts val="0"/>
-              </a:spcAft>
-              <a:defRPr sz="800">
+              <a:t>  {</a:t>
+            </a:r>
+          </a:p>
+          <a:p>
+            <a:pPr>
+              <a:lnSpc>
+                <a:spcPct val="100000"/>
+              </a:lnSpc>
+              <a:spcAft>
+                <a:spcPts val="600"/>
+              </a:spcAft>
+              <a:defRPr sz="1400">
+                <a:solidFill>
+                  <a:srgbClr val="8B949E"/>
+                </a:solidFill>
+                <a:latin typeface="Consolas"/>
+              </a:defRPr>
+            </a:pPr>
+            <a:r>
+              <a:t>    "frequencies": [...],</a:t>
+            </a:r>
+          </a:p>
+          <a:p>
+            <a:pPr>
+              <a:lnSpc>
+                <a:spcPct val="100000"/>
+              </a:lnSpc>
+              <a:spcAft>
+                <a:spcPts val="600"/>
+              </a:spcAft>
+              <a:defRPr sz="1400">
+                <a:solidFill>
+                  <a:srgbClr val="8B949E"/>
+                </a:solidFill>
+                <a:latin typeface="Consolas"/>
+              </a:defRPr>
+            </a:pPr>
+            <a:r>
+              <a:t>    "ir_intensities": [...],</a:t>
+            </a:r>
+          </a:p>
+          <a:p>
+            <a:pPr>
+              <a:lnSpc>
+                <a:spcPct val="100000"/>
+              </a:lnSpc>
+              <a:spcAft>
+                <a:spcPts val="600"/>
+              </a:spcAft>
+              <a:defRPr sz="1400">
+                <a:solidFill>
+                  <a:srgbClr val="8B949E"/>
+                </a:solidFill>
+                <a:latin typeface="Consolas"/>
+              </a:defRPr>
+            </a:pPr>
+            <a:r>
+              <a:t>    "eigenvectors": [[...]]</a:t>
+            </a:r>
+          </a:p>
+          <a:p>
+            <a:pPr>
+              <a:lnSpc>
+                <a:spcPct val="100000"/>
+              </a:lnSpc>
+              <a:spcAft>
+                <a:spcPts val="600"/>
+              </a:spcAft>
+              <a:defRPr sz="1400">
+                <a:solidFill>
+                  <a:srgbClr val="8B949E"/>
+                </a:solidFill>
+                <a:latin typeface="Consolas"/>
+              </a:defRPr>
+            </a:pPr>
+            <a:r>
+              <a:t>  }</a:t>
+            </a:r>
+          </a:p>
+          <a:p>
+            <a:pPr>
+              <a:lnSpc>
+                <a:spcPct val="100000"/>
+              </a:lnSpc>
+              <a:spcAft>
+                <a:spcPts val="600"/>
+              </a:spcAft>
+              <a:defRPr sz="1400">
                 <a:solidFill>
                   <a:srgbClr val="C9D1D9"/>
                 </a:solidFill>
                 <a:latin typeface="Consolas"/>
               </a:defRPr>
             </a:pPr>
-            <a:r>
-              <a:t>   Path: comparison_results/{molecule}/wb97xd/{molecule}_freq_anharm.log</a:t>
-            </a:r>
-          </a:p>
-          <a:p>
-            <a:pPr>
-              <a:lnSpc>
-                <a:spcPct val="100000"/>
-              </a:lnSpc>
-              <a:spcAft>
-                <a:spcPts val="0"/>
-              </a:spcAft>
-              <a:defRPr sz="800">
-                <a:solidFill>
-                  <a:srgbClr val="8B949E"/>
-                </a:solidFill>
-                <a:latin typeface="Consolas"/>
-              </a:defRPr>
-            </a:pPr>
-            <a:r>
-              <a:t>   Size: ~2-10 MB (text), 10,000-50,000 lines</a:t>
-            </a:r>
-          </a:p>
-          <a:p>
-            <a:pPr>
-              <a:lnSpc>
-                <a:spcPct val="100000"/>
-              </a:lnSpc>
-              <a:spcAft>
-                <a:spcPts val="0"/>
-              </a:spcAft>
-              <a:defRPr sz="800">
+          </a:p>
+          <a:p>
+            <a:pPr>
+              <a:lnSpc>
+                <a:spcPct val="100000"/>
+              </a:lnSpc>
+              <a:spcAft>
+                <a:spcPts val="600"/>
+              </a:spcAft>
+              <a:defRPr sz="1400">
                 <a:solidFill>
                   <a:srgbClr val="C9D1D9"/>
                 </a:solidFill>
                 <a:latin typeface="Consolas"/>
               </a:defRPr>
             </a:pPr>
-          </a:p>
-          <a:p>
-            <a:pPr>
-              <a:lnSpc>
-                <a:spcPct val="100000"/>
-              </a:lnSpc>
-              <a:spcAft>
-                <a:spcPts val="0"/>
-              </a:spcAft>
-              <a:defRPr sz="800">
-                <a:solidFill>
-                  <a:srgbClr val="C9D1D9"/>
-                </a:solidFill>
-                <a:latin typeface="Consolas"/>
-              </a:defRPr>
-            </a:pPr>
-            <a:r>
-              <a:t>   Parsing Targets:</a:t>
-            </a:r>
-          </a:p>
-          <a:p>
-            <a:pPr>
-              <a:lnSpc>
-                <a:spcPct val="100000"/>
-              </a:lnSpc>
-              <a:spcAft>
-                <a:spcPts val="0"/>
-              </a:spcAft>
-              <a:defRPr sz="800">
-                <a:solidFill>
-                  <a:srgbClr val="58A6FF"/>
-                </a:solidFill>
-                <a:latin typeface="Consolas"/>
-              </a:defRPr>
-            </a:pPr>
-            <a:r>
-              <a:t>   ┌──────────────────────────────────────────────────────────────────┐</a:t>
-            </a:r>
-          </a:p>
-          <a:p>
-            <a:pPr>
-              <a:lnSpc>
-                <a:spcPct val="100000"/>
-              </a:lnSpc>
-              <a:spcAft>
-                <a:spcPts val="0"/>
-              </a:spcAft>
-              <a:defRPr sz="800">
-                <a:solidFill>
-                  <a:srgbClr val="C9D1D9"/>
-                </a:solidFill>
-                <a:latin typeface="Consolas"/>
-              </a:defRPr>
-            </a:pPr>
-            <a:r>
-              <a:t>   │ • Harmonic frequencies:                                          │</a:t>
-            </a:r>
-          </a:p>
-          <a:p>
-            <a:pPr>
-              <a:lnSpc>
-                <a:spcPct val="100000"/>
-              </a:lnSpc>
-              <a:spcAft>
-                <a:spcPts val="0"/>
-              </a:spcAft>
-              <a:defRPr sz="800">
-                <a:solidFill>
-                  <a:srgbClr val="8B949E"/>
-                </a:solidFill>
-                <a:latin typeface="Consolas"/>
-              </a:defRPr>
-            </a:pPr>
-            <a:r>
-              <a:t>   │   Pattern: 'Frequencies --  500.00  1200.00  1500.00'           │</a:t>
-            </a:r>
-          </a:p>
-          <a:p>
-            <a:pPr>
-              <a:lnSpc>
-                <a:spcPct val="100000"/>
-              </a:lnSpc>
-              <a:spcAft>
-                <a:spcPts val="0"/>
-              </a:spcAft>
-              <a:defRPr sz="800">
-                <a:solidFill>
-                  <a:srgbClr val="C9D1D9"/>
-                </a:solidFill>
-                <a:latin typeface="Consolas"/>
-              </a:defRPr>
-            </a:pPr>
-            <a:r>
-              <a:t>   │                                                                  │</a:t>
-            </a:r>
-          </a:p>
-          <a:p>
-            <a:pPr>
-              <a:lnSpc>
-                <a:spcPct val="100000"/>
-              </a:lnSpc>
-              <a:spcAft>
-                <a:spcPts val="0"/>
-              </a:spcAft>
-              <a:defRPr sz="800">
-                <a:solidFill>
-                  <a:srgbClr val="C9D1D9"/>
-                </a:solidFill>
-                <a:latin typeface="Consolas"/>
-              </a:defRPr>
-            </a:pPr>
-            <a:r>
-              <a:t>   │ • Anharmonic frequencies:                                        │</a:t>
-            </a:r>
-          </a:p>
-          <a:p>
-            <a:pPr>
-              <a:lnSpc>
-                <a:spcPct val="100000"/>
-              </a:lnSpc>
-              <a:spcAft>
-                <a:spcPts val="0"/>
-              </a:spcAft>
-              <a:defRPr sz="800">
-                <a:solidFill>
-                  <a:srgbClr val="8B949E"/>
-                </a:solidFill>
-                <a:latin typeface="Consolas"/>
-              </a:defRPr>
-            </a:pPr>
-            <a:r>
-              <a:t>   │   Pattern: 'Fundamental Bands (cm-1)'                            │</a:t>
-            </a:r>
-          </a:p>
-          <a:p>
-            <a:pPr>
-              <a:lnSpc>
-                <a:spcPct val="100000"/>
-              </a:lnSpc>
-              <a:spcAft>
-                <a:spcPts val="0"/>
-              </a:spcAft>
-              <a:defRPr sz="800">
-                <a:solidFill>
-                  <a:srgbClr val="C9D1D9"/>
-                </a:solidFill>
-                <a:latin typeface="Consolas"/>
-              </a:defRPr>
-            </a:pPr>
-            <a:r>
-              <a:t>   │                                                                  │</a:t>
-            </a:r>
-          </a:p>
-          <a:p>
-            <a:pPr>
-              <a:lnSpc>
-                <a:spcPct val="100000"/>
-              </a:lnSpc>
-              <a:spcAft>
-                <a:spcPts val="0"/>
-              </a:spcAft>
-              <a:defRPr sz="800">
-                <a:solidFill>
-                  <a:srgbClr val="C9D1D9"/>
-                </a:solidFill>
-                <a:latin typeface="Consolas"/>
-              </a:defRPr>
-            </a:pPr>
-            <a:r>
-              <a:t>   │ • Overtones and combination bands:                               │</a:t>
-            </a:r>
-          </a:p>
-          <a:p>
-            <a:pPr>
-              <a:lnSpc>
-                <a:spcPct val="100000"/>
-              </a:lnSpc>
-              <a:spcAft>
-                <a:spcPts val="0"/>
-              </a:spcAft>
-              <a:defRPr sz="800">
-                <a:solidFill>
-                  <a:srgbClr val="8B949E"/>
-                </a:solidFill>
-                <a:latin typeface="Consolas"/>
-              </a:defRPr>
-            </a:pPr>
-            <a:r>
-              <a:t>   │   Pattern: '2(1)' or '1(1) + 2(1)'                               │</a:t>
-            </a:r>
-          </a:p>
-          <a:p>
-            <a:pPr>
-              <a:lnSpc>
-                <a:spcPct val="100000"/>
-              </a:lnSpc>
-              <a:spcAft>
-                <a:spcPts val="0"/>
-              </a:spcAft>
-              <a:defRPr sz="800">
-                <a:solidFill>
-                  <a:srgbClr val="C9D1D9"/>
-                </a:solidFill>
-                <a:latin typeface="Consolas"/>
-              </a:defRPr>
-            </a:pPr>
-            <a:r>
-              <a:t>   │                                                                  │</a:t>
-            </a:r>
-          </a:p>
-          <a:p>
-            <a:pPr>
-              <a:lnSpc>
-                <a:spcPct val="100000"/>
-              </a:lnSpc>
-              <a:spcAft>
-                <a:spcPts val="0"/>
-              </a:spcAft>
-              <a:defRPr sz="800">
-                <a:solidFill>
-                  <a:srgbClr val="C9D1D9"/>
-                </a:solidFill>
-                <a:latin typeface="Consolas"/>
-              </a:defRPr>
-            </a:pPr>
-            <a:r>
-              <a:t>   │ • IR intensities:                                                │</a:t>
-            </a:r>
-          </a:p>
-          <a:p>
-            <a:pPr>
-              <a:lnSpc>
-                <a:spcPct val="100000"/>
-              </a:lnSpc>
-              <a:spcAft>
-                <a:spcPts val="0"/>
-              </a:spcAft>
-              <a:defRPr sz="800">
-                <a:solidFill>
-                  <a:srgbClr val="8B949E"/>
-                </a:solidFill>
-                <a:latin typeface="Consolas"/>
-              </a:defRPr>
-            </a:pPr>
-            <a:r>
-              <a:t>   │   Pattern: 'IR Inten    --   25.00   50.00  100.00'             │</a:t>
-            </a:r>
-          </a:p>
-          <a:p>
-            <a:pPr>
-              <a:lnSpc>
-                <a:spcPct val="100000"/>
-              </a:lnSpc>
-              <a:spcAft>
-                <a:spcPts val="0"/>
-              </a:spcAft>
-              <a:defRPr sz="800">
-                <a:solidFill>
-                  <a:srgbClr val="C9D1D9"/>
-                </a:solidFill>
-                <a:latin typeface="Consolas"/>
-              </a:defRPr>
-            </a:pPr>
-            <a:r>
-              <a:t>   │                                                                  │</a:t>
-            </a:r>
-          </a:p>
-          <a:p>
-            <a:pPr>
-              <a:lnSpc>
-                <a:spcPct val="100000"/>
-              </a:lnSpc>
-              <a:spcAft>
-                <a:spcPts val="0"/>
-              </a:spcAft>
-              <a:defRPr sz="800">
-                <a:solidFill>
-                  <a:srgbClr val="C9D1D9"/>
-                </a:solidFill>
-                <a:latin typeface="Consolas"/>
-              </a:defRPr>
-            </a:pPr>
-            <a:r>
-              <a:t>   │ • Normal mode eigenvectors:                                      │</a:t>
-            </a:r>
-          </a:p>
-          <a:p>
-            <a:pPr>
-              <a:lnSpc>
-                <a:spcPct val="100000"/>
-              </a:lnSpc>
-              <a:spcAft>
-                <a:spcPts val="0"/>
-              </a:spcAft>
-              <a:defRPr sz="800">
-                <a:solidFill>
-                  <a:srgbClr val="8B949E"/>
-                </a:solidFill>
-                <a:latin typeface="Consolas"/>
-              </a:defRPr>
-            </a:pPr>
-            <a:r>
-              <a:t>   │   3N-6 modes × N atoms × 3 coordinates                           │</a:t>
-            </a:r>
-          </a:p>
-          <a:p>
-            <a:pPr>
-              <a:lnSpc>
-                <a:spcPct val="100000"/>
-              </a:lnSpc>
-              <a:spcAft>
-                <a:spcPts val="0"/>
-              </a:spcAft>
-              <a:defRPr sz="800">
-                <a:solidFill>
-                  <a:srgbClr val="8B949E"/>
-                </a:solidFill>
-                <a:latin typeface="Consolas"/>
-              </a:defRPr>
-            </a:pPr>
-            <a:r>
-              <a:t>   │   Pattern: 'Atom  AN      X      Y      Z'                       │</a:t>
-            </a:r>
-          </a:p>
-          <a:p>
-            <a:pPr>
-              <a:lnSpc>
-                <a:spcPct val="100000"/>
-              </a:lnSpc>
-              <a:spcAft>
-                <a:spcPts val="0"/>
-              </a:spcAft>
-              <a:defRPr sz="800">
-                <a:solidFill>
-                  <a:srgbClr val="58A6FF"/>
-                </a:solidFill>
-                <a:latin typeface="Consolas"/>
-              </a:defRPr>
-            </a:pPr>
-            <a:r>
-              <a:t>   └──────────────────────────────────────────────────────────────────┘</a:t>
-            </a:r>
-          </a:p>
-          <a:p>
-            <a:pPr>
-              <a:lnSpc>
-                <a:spcPct val="100000"/>
-              </a:lnSpc>
-              <a:spcAft>
-                <a:spcPts val="0"/>
-              </a:spcAft>
-              <a:defRPr sz="800">
-                <a:solidFill>
-                  <a:srgbClr val="C9D1D9"/>
-                </a:solidFill>
-                <a:latin typeface="Consolas"/>
-              </a:defRPr>
-            </a:pPr>
-          </a:p>
-          <a:p>
-            <a:pPr>
-              <a:lnSpc>
-                <a:spcPct val="100000"/>
-              </a:lnSpc>
-              <a:spcAft>
-                <a:spcPts val="0"/>
-              </a:spcAft>
-              <a:defRPr sz="800">
-                <a:solidFill>
-                  <a:srgbClr val="DB6D28"/>
-                </a:solidFill>
-                <a:latin typeface="Consolas"/>
-              </a:defRPr>
-            </a:pPr>
-            <a:r>
-              <a:t>   Challenges:</a:t>
-            </a:r>
-          </a:p>
-          <a:p>
-            <a:pPr>
-              <a:lnSpc>
-                <a:spcPct val="100000"/>
-              </a:lnSpc>
-              <a:spcAft>
-                <a:spcPts val="0"/>
-              </a:spcAft>
-              <a:defRPr sz="800">
-                <a:solidFill>
-                  <a:srgbClr val="C9D1D9"/>
-                </a:solidFill>
-                <a:latin typeface="Consolas"/>
-              </a:defRPr>
-            </a:pPr>
-            <a:r>
-              <a:t>   • Multi-column format (3 modes per block)</a:t>
-            </a:r>
-          </a:p>
-          <a:p>
-            <a:pPr>
-              <a:lnSpc>
-                <a:spcPct val="100000"/>
-              </a:lnSpc>
-              <a:spcAft>
-                <a:spcPts val="0"/>
-              </a:spcAft>
-              <a:defRPr sz="800">
-                <a:solidFill>
-                  <a:srgbClr val="C9D1D9"/>
-                </a:solidFill>
-                <a:latin typeface="Consolas"/>
-              </a:defRPr>
-            </a:pPr>
-            <a:r>
-              <a:t>   • Scattered data across file (search 1000s of lines)</a:t>
-            </a:r>
-          </a:p>
-          <a:p>
-            <a:pPr>
-              <a:lnSpc>
-                <a:spcPct val="100000"/>
-              </a:lnSpc>
-              <a:spcAft>
-                <a:spcPts val="0"/>
-              </a:spcAft>
-              <a:defRPr sz="800">
-                <a:solidFill>
-                  <a:srgbClr val="C9D1D9"/>
-                </a:solidFill>
-                <a:latin typeface="Consolas"/>
-              </a:defRPr>
-            </a:pPr>
-            <a:r>
-              <a:t>   • Anharmonic section sometimes missing (wb97xd issues)</a:t>
-            </a:r>
-          </a:p>
-          <a:p>
-            <a:pPr>
-              <a:lnSpc>
-                <a:spcPct val="100000"/>
-              </a:lnSpc>
-              <a:spcAft>
-                <a:spcPts val="0"/>
-              </a:spcAft>
-              <a:defRPr sz="800">
-                <a:solidFill>
-                  <a:srgbClr val="C9D1D9"/>
-                </a:solidFill>
-                <a:latin typeface="Consolas"/>
-              </a:defRPr>
-            </a:pPr>
-          </a:p>
-          <a:p>
-            <a:pPr>
-              <a:lnSpc>
-                <a:spcPct val="100000"/>
-              </a:lnSpc>
-              <a:spcAft>
-                <a:spcPts val="0"/>
-              </a:spcAft>
-              <a:defRPr sz="800">
-                <a:solidFill>
-                  <a:srgbClr val="C9D1D9"/>
-                </a:solidFill>
-                <a:latin typeface="Consolas"/>
-              </a:defRPr>
-            </a:pPr>
-          </a:p>
-          <a:p>
-            <a:pPr>
-              <a:lnSpc>
-                <a:spcPct val="100000"/>
-              </a:lnSpc>
-              <a:spcAft>
-                <a:spcPts val="0"/>
-              </a:spcAft>
-              <a:defRPr sz="800">
-                <a:solidFill>
-                  <a:srgbClr val="58A6FF"/>
-                </a:solidFill>
-                <a:latin typeface="Consolas"/>
-              </a:defRPr>
-            </a:pPr>
-            <a:r>
-              <a:t>2. JSON RESULTS FILES (ML calculations)</a:t>
-            </a:r>
-          </a:p>
-          <a:p>
-            <a:pPr>
-              <a:lnSpc>
-                <a:spcPct val="100000"/>
-              </a:lnSpc>
-              <a:spcAft>
-                <a:spcPts val="0"/>
-              </a:spcAft>
-              <a:defRPr sz="800">
-                <a:solidFill>
-                  <a:srgbClr val="8B949E"/>
-                </a:solidFill>
-                <a:latin typeface="Consolas"/>
-              </a:defRPr>
-            </a:pPr>
-            <a:r>
-              <a:t>   ──────────────────────────────────────</a:t>
-            </a:r>
-          </a:p>
-          <a:p>
-            <a:pPr>
-              <a:lnSpc>
-                <a:spcPct val="100000"/>
-              </a:lnSpc>
-              <a:spcAft>
-                <a:spcPts val="0"/>
-              </a:spcAft>
-              <a:defRPr sz="800">
-                <a:solidFill>
-                  <a:srgbClr val="C9D1D9"/>
-                </a:solidFill>
-                <a:latin typeface="Consolas"/>
-              </a:defRPr>
-            </a:pPr>
-            <a:r>
-              <a:t>   Paths: comparison_results/{molecule}/{energy}_{dipole}/results.json</a:t>
-            </a:r>
-          </a:p>
-          <a:p>
-            <a:pPr>
-              <a:lnSpc>
-                <a:spcPct val="100000"/>
-              </a:lnSpc>
-              <a:spcAft>
-                <a:spcPts val="0"/>
-              </a:spcAft>
-              <a:defRPr sz="800">
-                <a:solidFill>
-                  <a:srgbClr val="8B949E"/>
-                </a:solidFill>
-                <a:latin typeface="Consolas"/>
-              </a:defRPr>
-            </a:pPr>
-            <a:r>
-              <a:t>   Examples:</a:t>
-            </a:r>
-          </a:p>
-          <a:p>
-            <a:pPr>
-              <a:lnSpc>
-                <a:spcPct val="100000"/>
-              </a:lnSpc>
-              <a:spcAft>
-                <a:spcPts val="0"/>
-              </a:spcAft>
-              <a:defRPr sz="800">
-                <a:solidFill>
-                  <a:srgbClr val="8B949E"/>
-                </a:solidFill>
-                <a:latin typeface="Consolas"/>
-              </a:defRPr>
-            </a:pPr>
-            <a:r>
-              <a:t>     • mace_mp_espaloma/results.json</a:t>
-            </a:r>
-          </a:p>
-          <a:p>
-            <a:pPr>
-              <a:lnSpc>
-                <a:spcPct val="100000"/>
-              </a:lnSpc>
-              <a:spcAft>
-                <a:spcPts val="0"/>
-              </a:spcAft>
-              <a:defRPr sz="800">
-                <a:solidFill>
-                  <a:srgbClr val="8B949E"/>
-                </a:solidFill>
-                <a:latin typeface="Consolas"/>
-              </a:defRPr>
-            </a:pPr>
-            <a:r>
-              <a:t>     • mace_omol_mace_ml/results.json</a:t>
-            </a:r>
-          </a:p>
-          <a:p>
-            <a:pPr>
-              <a:lnSpc>
-                <a:spcPct val="100000"/>
-              </a:lnSpc>
-              <a:spcAft>
-                <a:spcPts val="0"/>
-              </a:spcAft>
-              <a:defRPr sz="800">
-                <a:solidFill>
-                  <a:srgbClr val="C9D1D9"/>
-                </a:solidFill>
-                <a:latin typeface="Consolas"/>
-              </a:defRPr>
-            </a:pPr>
-          </a:p>
-          <a:p>
-            <a:pPr>
-              <a:lnSpc>
-                <a:spcPct val="100000"/>
-              </a:lnSpc>
-              <a:spcAft>
-                <a:spcPts val="0"/>
-              </a:spcAft>
-              <a:defRPr sz="800">
-                <a:solidFill>
-                  <a:srgbClr val="C9D1D9"/>
-                </a:solidFill>
-                <a:latin typeface="Consolas"/>
-              </a:defRPr>
-            </a:pPr>
-            <a:r>
-              <a:t>   Structure:</a:t>
-            </a:r>
-          </a:p>
-          <a:p>
-            <a:pPr>
-              <a:lnSpc>
-                <a:spcPct val="100000"/>
-              </a:lnSpc>
-              <a:spcAft>
-                <a:spcPts val="0"/>
-              </a:spcAft>
-              <a:defRPr sz="800">
-                <a:solidFill>
-                  <a:srgbClr val="58A6FF"/>
-                </a:solidFill>
-                <a:latin typeface="Consolas"/>
-              </a:defRPr>
-            </a:pPr>
-            <a:r>
-              <a:t>   ┌──────────────────────────────────────────────────────────────────┐</a:t>
-            </a:r>
-          </a:p>
-          <a:p>
-            <a:pPr>
-              <a:lnSpc>
-                <a:spcPct val="100000"/>
-              </a:lnSpc>
-              <a:spcAft>
-                <a:spcPts val="0"/>
-              </a:spcAft>
-              <a:defRPr sz="800">
-                <a:solidFill>
-                  <a:srgbClr val="C9D1D9"/>
-                </a:solidFill>
-                <a:latin typeface="Consolas"/>
-              </a:defRPr>
-            </a:pPr>
-            <a:r>
-              <a:t>   │ {                                                                │</a:t>
-            </a:r>
-          </a:p>
-          <a:p>
-            <a:pPr>
-              <a:lnSpc>
-                <a:spcPct val="100000"/>
-              </a:lnSpc>
-              <a:spcAft>
-                <a:spcPts val="0"/>
-              </a:spcAft>
-              <a:defRPr sz="800">
-                <a:solidFill>
-                  <a:srgbClr val="8B949E"/>
-                </a:solidFill>
-                <a:latin typeface="Consolas"/>
-              </a:defRPr>
-            </a:pPr>
-            <a:r>
-              <a:t>   │   "calculator_type": "ml",                                      │</a:t>
-            </a:r>
-          </a:p>
-          <a:p>
-            <a:pPr>
-              <a:lnSpc>
-                <a:spcPct val="100000"/>
-              </a:lnSpc>
-              <a:spcAft>
-                <a:spcPts val="0"/>
-              </a:spcAft>
-              <a:defRPr sz="800">
-                <a:solidFill>
-                  <a:srgbClr val="8B949E"/>
-                </a:solidFill>
-                <a:latin typeface="Consolas"/>
-              </a:defRPr>
-            </a:pPr>
-            <a:r>
-              <a:t>   │   "energy_calculator": "mace_mp",                               │</a:t>
-            </a:r>
-          </a:p>
-          <a:p>
-            <a:pPr>
-              <a:lnSpc>
-                <a:spcPct val="100000"/>
-              </a:lnSpc>
-              <a:spcAft>
-                <a:spcPts val="0"/>
-              </a:spcAft>
-              <a:defRPr sz="800">
-                <a:solidFill>
-                  <a:srgbClr val="8B949E"/>
-                </a:solidFill>
-                <a:latin typeface="Consolas"/>
-              </a:defRPr>
-            </a:pPr>
-            <a:r>
-              <a:t>   │   "dipole_calculator": "espaloma",                              │</a:t>
-            </a:r>
-          </a:p>
-          <a:p>
-            <a:pPr>
-              <a:lnSpc>
-                <a:spcPct val="100000"/>
-              </a:lnSpc>
-              <a:spcAft>
-                <a:spcPts val="0"/>
-              </a:spcAft>
-              <a:defRPr sz="800">
-                <a:solidFill>
-                  <a:srgbClr val="8B949E"/>
-                </a:solidFill>
-                <a:latin typeface="Consolas"/>
-              </a:defRPr>
-            </a:pPr>
-            <a:r>
-              <a:t>   │   "frequencies": {                                               │</a:t>
-            </a:r>
-          </a:p>
-          <a:p>
-            <a:pPr>
-              <a:lnSpc>
-                <a:spcPct val="100000"/>
-              </a:lnSpc>
-              <a:spcAft>
-                <a:spcPts val="0"/>
-              </a:spcAft>
-              <a:defRPr sz="800">
-                <a:solidFill>
-                  <a:srgbClr val="57AB5A"/>
-                </a:solidFill>
-                <a:latin typeface="Consolas"/>
-              </a:defRPr>
-            </a:pPr>
-            <a:r>
-              <a:t>   │     "harmonic": [500.0, 1200.0, 1500.0, ...],                   │</a:t>
-            </a:r>
-          </a:p>
-          <a:p>
-            <a:pPr>
-              <a:lnSpc>
-                <a:spcPct val="100000"/>
-              </a:lnSpc>
-              <a:spcAft>
-                <a:spcPts val="0"/>
-              </a:spcAft>
-              <a:defRPr sz="800">
-                <a:solidFill>
-                  <a:srgbClr val="57AB5A"/>
-                </a:solidFill>
-                <a:latin typeface="Consolas"/>
-              </a:defRPr>
-            </a:pPr>
-            <a:r>
-              <a:t>   │     "anharmonic": [498.0, 1195.0, 1497.0, ...]                  │</a:t>
-            </a:r>
-          </a:p>
-          <a:p>
-            <a:pPr>
-              <a:lnSpc>
-                <a:spcPct val="100000"/>
-              </a:lnSpc>
-              <a:spcAft>
-                <a:spcPts val="0"/>
-              </a:spcAft>
-              <a:defRPr sz="800">
-                <a:solidFill>
-                  <a:srgbClr val="8B949E"/>
-                </a:solidFill>
-                <a:latin typeface="Consolas"/>
-              </a:defRPr>
-            </a:pPr>
-            <a:r>
-              <a:t>   │   },                                                             │</a:t>
-            </a:r>
-          </a:p>
-          <a:p>
-            <a:pPr>
-              <a:lnSpc>
-                <a:spcPct val="100000"/>
-              </a:lnSpc>
-              <a:spcAft>
-                <a:spcPts val="0"/>
-              </a:spcAft>
-              <a:defRPr sz="800">
-                <a:solidFill>
-                  <a:srgbClr val="8B949E"/>
-                </a:solidFill>
-                <a:latin typeface="Consolas"/>
-              </a:defRPr>
-            </a:pPr>
-            <a:r>
-              <a:t>   │   "ir_intensities": {                                            │</a:t>
-            </a:r>
-          </a:p>
-          <a:p>
-            <a:pPr>
-              <a:lnSpc>
-                <a:spcPct val="100000"/>
-              </a:lnSpc>
-              <a:spcAft>
-                <a:spcPts val="0"/>
-              </a:spcAft>
-              <a:defRPr sz="800">
-                <a:solidFill>
-                  <a:srgbClr val="57AB5A"/>
-                </a:solidFill>
-                <a:latin typeface="Consolas"/>
-              </a:defRPr>
-            </a:pPr>
-            <a:r>
-              <a:t>   │     "harmonic": [25.0, 50.0, 100.0, ...],                       │</a:t>
-            </a:r>
-          </a:p>
-          <a:p>
-            <a:pPr>
-              <a:lnSpc>
-                <a:spcPct val="100000"/>
-              </a:lnSpc>
-              <a:spcAft>
-                <a:spcPts val="0"/>
-              </a:spcAft>
-              <a:defRPr sz="800">
-                <a:solidFill>
-                  <a:srgbClr val="57AB5A"/>
-                </a:solidFill>
-                <a:latin typeface="Consolas"/>
-              </a:defRPr>
-            </a:pPr>
-            <a:r>
-              <a:t>   │     "anharmonic": [26.0, 51.0, 102.0, ...]                      │</a:t>
-            </a:r>
-          </a:p>
-          <a:p>
-            <a:pPr>
-              <a:lnSpc>
-                <a:spcPct val="100000"/>
-              </a:lnSpc>
-              <a:spcAft>
-                <a:spcPts val="0"/>
-              </a:spcAft>
-              <a:defRPr sz="800">
-                <a:solidFill>
-                  <a:srgbClr val="8B949E"/>
-                </a:solidFill>
-                <a:latin typeface="Consolas"/>
-              </a:defRPr>
-            </a:pPr>
-            <a:r>
-              <a:t>   │   },                                                             │</a:t>
-            </a:r>
-          </a:p>
-          <a:p>
-            <a:pPr>
-              <a:lnSpc>
-                <a:spcPct val="100000"/>
-              </a:lnSpc>
-              <a:spcAft>
-                <a:spcPts val="0"/>
-              </a:spcAft>
-              <a:defRPr sz="800">
-                <a:solidFill>
-                  <a:srgbClr val="8B949E"/>
-                </a:solidFill>
-                <a:latin typeface="Consolas"/>
-              </a:defRPr>
-            </a:pPr>
-            <a:r>
-              <a:t>   │   "eigenvectors": [[...], [...], ...],                          │</a:t>
-            </a:r>
-          </a:p>
-          <a:p>
-            <a:pPr>
-              <a:lnSpc>
-                <a:spcPct val="100000"/>
-              </a:lnSpc>
-              <a:spcAft>
-                <a:spcPts val="0"/>
-              </a:spcAft>
-              <a:defRPr sz="800">
-                <a:solidFill>
-                  <a:srgbClr val="8B949E"/>
-                </a:solidFill>
-                <a:latin typeface="Consolas"/>
-              </a:defRPr>
-            </a:pPr>
-            <a:r>
-              <a:t>   │   "runtime_s": 45.2                                             │</a:t>
-            </a:r>
-          </a:p>
-          <a:p>
-            <a:pPr>
-              <a:lnSpc>
-                <a:spcPct val="100000"/>
-              </a:lnSpc>
-              <a:spcAft>
-                <a:spcPts val="0"/>
-              </a:spcAft>
-              <a:defRPr sz="800">
-                <a:solidFill>
-                  <a:srgbClr val="C9D1D9"/>
-                </a:solidFill>
-                <a:latin typeface="Consolas"/>
-              </a:defRPr>
-            </a:pPr>
-            <a:r>
-              <a:t>   │ }                                                                │</a:t>
-            </a:r>
-          </a:p>
-          <a:p>
-            <a:pPr>
-              <a:lnSpc>
-                <a:spcPct val="100000"/>
-              </a:lnSpc>
-              <a:spcAft>
-                <a:spcPts val="0"/>
-              </a:spcAft>
-              <a:defRPr sz="800">
-                <a:solidFill>
-                  <a:srgbClr val="58A6FF"/>
-                </a:solidFill>
-                <a:latin typeface="Consolas"/>
-              </a:defRPr>
-            </a:pPr>
-            <a:r>
-              <a:t>   └──────────────────────────────────────────────────────────────────┘</a:t>
-            </a:r>
-          </a:p>
-          <a:p>
-            <a:pPr>
-              <a:lnSpc>
-                <a:spcPct val="100000"/>
-              </a:lnSpc>
-              <a:spcAft>
-                <a:spcPts val="0"/>
-              </a:spcAft>
-              <a:defRPr sz="800">
-                <a:solidFill>
-                  <a:srgbClr val="C9D1D9"/>
-                </a:solidFill>
-                <a:latin typeface="Consolas"/>
-              </a:defRPr>
-            </a:pPr>
-          </a:p>
-          <a:p>
-            <a:pPr>
-              <a:lnSpc>
-                <a:spcPct val="100000"/>
-              </a:lnSpc>
-              <a:spcAft>
-                <a:spcPts val="0"/>
-              </a:spcAft>
-              <a:defRPr sz="800">
-                <a:solidFill>
-                  <a:srgbClr val="C9D1D9"/>
-                </a:solidFill>
-                <a:latin typeface="Consolas"/>
-              </a:defRPr>
-            </a:pPr>
-          </a:p>
-          <a:p>
-            <a:pPr>
-              <a:lnSpc>
-                <a:spcPct val="100000"/>
-              </a:lnSpc>
-              <a:spcAft>
-                <a:spcPts val="0"/>
-              </a:spcAft>
-              <a:defRPr sz="800">
-                <a:solidFill>
-                  <a:srgbClr val="BC8CFF"/>
-                </a:solidFill>
-                <a:latin typeface="Consolas"/>
-              </a:defRPr>
-            </a:pPr>
-            <a:r>
-              <a:t>PARSER IMPLEMENTATION:</a:t>
-            </a:r>
-          </a:p>
-          <a:p>
-            <a:pPr>
-              <a:lnSpc>
-                <a:spcPct val="100000"/>
-              </a:lnSpc>
-              <a:spcAft>
-                <a:spcPts val="0"/>
-              </a:spcAft>
-              <a:defRPr sz="800">
-                <a:solidFill>
-                  <a:srgbClr val="C9D1D9"/>
-                </a:solidFill>
-                <a:latin typeface="Consolas"/>
-              </a:defRPr>
-            </a:pPr>
-            <a:r>
-              <a:t>  • gaussian_parser.py: Regex-based Gaussian log parsing</a:t>
-            </a:r>
-          </a:p>
-          <a:p>
-            <a:pPr>
-              <a:lnSpc>
-                <a:spcPct val="100000"/>
-              </a:lnSpc>
-              <a:spcAft>
-                <a:spcPts val="0"/>
-              </a:spcAft>
-              <a:defRPr sz="800">
-                <a:solidFill>
-                  <a:srgbClr val="C9D1D9"/>
-                </a:solidFill>
-                <a:latin typeface="Consolas"/>
-              </a:defRPr>
-            </a:pPr>
-            <a:r>
-              <a:t>  • results_manager.py: JSON loading and validation</a:t>
-            </a:r>
-          </a:p>
-          <a:p>
-            <a:pPr>
-              <a:lnSpc>
-                <a:spcPct val="100000"/>
-              </a:lnSpc>
-              <a:spcAft>
-                <a:spcPts val="0"/>
-              </a:spcAft>
-              <a:defRPr sz="800">
-                <a:solidFill>
-                  <a:srgbClr val="C9D1D9"/>
-                </a:solidFill>
-                <a:latin typeface="Consolas"/>
-              </a:defRPr>
-            </a:pPr>
-            <a:r>
-              <a:t>  • comparison_workflow.py: Aggregates all results for analysis</a:t>
+            <a:r>
+              <a:t>  → Structured, easy to parse</a:t>
             </a:r>
           </a:p>
         </p:txBody>

</xml_diff>

<commit_message>
Add workflow management slide to technical details
Fourth slide covering automation features:
- Automatic directory structure creation
- Smart file detection and resume capability
- Auto-detection of DFT baseline
- Results aggregation across all methods

Clean, minimal style matching other slides
</commit_message>
<xml_diff>
--- a/presentation/technical_details.pptx
+++ b/presentation/technical_details.pptx
@@ -8,6 +8,7 @@
     <p:sldId id="256" r:id="rId7"/>
     <p:sldId id="257" r:id="rId8"/>
     <p:sldId id="258" r:id="rId9"/>
+    <p:sldId id="259" r:id="rId10"/>
   </p:sldIdLst>
   <p:sldSz cx="9144000" cy="6858000" type="screen4x3"/>
   <p:notesSz cx="6858000" cy="9144000"/>
@@ -4454,6 +4455,561 @@
             </a:pPr>
             <a:r>
               <a:t>  → Structured, easy to parse</a:t>
+            </a:r>
+          </a:p>
+        </p:txBody>
+      </p:sp>
+    </p:spTree>
+  </p:cSld>
+  <p:clrMapOvr>
+    <a:masterClrMapping/>
+  </p:clrMapOvr>
+</p:sld>
+</file>
+
+<file path=ppt/slides/slide4.xml><?xml version="1.0" encoding="utf-8"?>
+<p:sld xmlns:a="http://schemas.openxmlformats.org/drawingml/2006/main" xmlns:p="http://schemas.openxmlformats.org/presentationml/2006/main" xmlns:r="http://schemas.openxmlformats.org/officeDocument/2006/relationships">
+  <p:cSld>
+    <p:bg>
+      <p:bgPr>
+        <a:solidFill>
+          <a:srgbClr val="0D1117"/>
+        </a:solidFill>
+        <a:effectLst/>
+      </p:bgPr>
+    </p:bg>
+    <p:spTree>
+      <p:nvGrpSpPr>
+        <p:cNvPr id="1" name=""/>
+        <p:cNvGrpSpPr/>
+        <p:nvPr/>
+      </p:nvGrpSpPr>
+      <p:grpSpPr/>
+      <p:sp>
+        <p:nvSpPr>
+          <p:cNvPr id="2" name="TextBox 1"/>
+          <p:cNvSpPr txBox="1"/>
+          <p:nvPr/>
+        </p:nvSpPr>
+        <p:spPr>
+          <a:xfrm>
+            <a:off x="457200" y="365760"/>
+            <a:ext cx="8229600" cy="457200"/>
+          </a:xfrm>
+          <a:prstGeom prst="rect">
+            <a:avLst/>
+          </a:prstGeom>
+          <a:noFill/>
+        </p:spPr>
+        <p:txBody>
+          <a:bodyPr wrap="none">
+            <a:spAutoFit/>
+          </a:bodyPr>
+          <a:lstStyle/>
+          <a:p>
+            <a:pPr>
+              <a:defRPr sz="2800" b="1">
+                <a:solidFill>
+                  <a:srgbClr val="58A6FF"/>
+                </a:solidFill>
+                <a:latin typeface="Consolas"/>
+              </a:defRPr>
+            </a:pPr>
+            <a:r>
+              <a:t>$ cat workflow_automation.md</a:t>
+            </a:r>
+          </a:p>
+        </p:txBody>
+      </p:sp>
+      <p:sp>
+        <p:nvSpPr>
+          <p:cNvPr id="3" name="TextBox 2"/>
+          <p:cNvSpPr txBox="1"/>
+          <p:nvPr/>
+        </p:nvSpPr>
+        <p:spPr>
+          <a:xfrm>
+            <a:off x="731520" y="1097280"/>
+            <a:ext cx="7680960" cy="4389120"/>
+          </a:xfrm>
+          <a:prstGeom prst="rect">
+            <a:avLst/>
+          </a:prstGeom>
+          <a:noFill/>
+        </p:spPr>
+        <p:txBody>
+          <a:bodyPr wrap="none">
+            <a:spAutoFit/>
+          </a:bodyPr>
+          <a:lstStyle/>
+          <a:p>
+            <a:pPr>
+              <a:lnSpc>
+                <a:spcPct val="100000"/>
+              </a:lnSpc>
+              <a:spcAft>
+                <a:spcPts val="600"/>
+              </a:spcAft>
+              <a:defRPr sz="1400">
+                <a:solidFill>
+                  <a:srgbClr val="58A6FF"/>
+                </a:solidFill>
+                <a:latin typeface="Consolas"/>
+              </a:defRPr>
+            </a:pPr>
+            <a:r>
+              <a:t># Automatic Directory Structure</a:t>
+            </a:r>
+          </a:p>
+          <a:p>
+            <a:pPr>
+              <a:lnSpc>
+                <a:spcPct val="100000"/>
+              </a:lnSpc>
+              <a:spcAft>
+                <a:spcPts val="600"/>
+              </a:spcAft>
+              <a:defRPr sz="1400">
+                <a:solidFill>
+                  <a:srgbClr val="C9D1D9"/>
+                </a:solidFill>
+                <a:latin typeface="Consolas"/>
+              </a:defRPr>
+            </a:pPr>
+          </a:p>
+          <a:p>
+            <a:pPr>
+              <a:lnSpc>
+                <a:spcPct val="100000"/>
+              </a:lnSpc>
+              <a:spcAft>
+                <a:spcPts val="600"/>
+              </a:spcAft>
+              <a:defRPr sz="1400">
+                <a:solidFill>
+                  <a:srgbClr val="8B949E"/>
+                </a:solidFill>
+                <a:latin typeface="Consolas"/>
+              </a:defRPr>
+            </a:pPr>
+            <a:r>
+              <a:t>  comparison_results/</a:t>
+            </a:r>
+          </a:p>
+          <a:p>
+            <a:pPr>
+              <a:lnSpc>
+                <a:spcPct val="100000"/>
+              </a:lnSpc>
+              <a:spcAft>
+                <a:spcPts val="600"/>
+              </a:spcAft>
+              <a:defRPr sz="1400">
+                <a:solidFill>
+                  <a:srgbClr val="8B949E"/>
+                </a:solidFill>
+                <a:latin typeface="Consolas"/>
+              </a:defRPr>
+            </a:pPr>
+            <a:r>
+              <a:t>    └─ {molecule}/</a:t>
+            </a:r>
+          </a:p>
+          <a:p>
+            <a:pPr>
+              <a:lnSpc>
+                <a:spcPct val="100000"/>
+              </a:lnSpc>
+              <a:spcAft>
+                <a:spcPts val="600"/>
+              </a:spcAft>
+              <a:defRPr sz="1400">
+                <a:solidFill>
+                  <a:srgbClr val="8B949E"/>
+                </a:solidFill>
+                <a:latin typeface="Consolas"/>
+              </a:defRPr>
+            </a:pPr>
+            <a:r>
+              <a:t>       ├─ geometry_opt/</a:t>
+            </a:r>
+          </a:p>
+          <a:p>
+            <a:pPr>
+              <a:lnSpc>
+                <a:spcPct val="100000"/>
+              </a:lnSpc>
+              <a:spcAft>
+                <a:spcPts val="600"/>
+              </a:spcAft>
+              <a:defRPr sz="1400">
+                <a:solidFill>
+                  <a:srgbClr val="8B949E"/>
+                </a:solidFill>
+                <a:latin typeface="Consolas"/>
+              </a:defRPr>
+            </a:pPr>
+            <a:r>
+              <a:t>       ├─ wb97xd/</a:t>
+            </a:r>
+          </a:p>
+          <a:p>
+            <a:pPr>
+              <a:lnSpc>
+                <a:spcPct val="100000"/>
+              </a:lnSpc>
+              <a:spcAft>
+                <a:spcPts val="600"/>
+              </a:spcAft>
+              <a:defRPr sz="1400">
+                <a:solidFill>
+                  <a:srgbClr val="8B949E"/>
+                </a:solidFill>
+                <a:latin typeface="Consolas"/>
+              </a:defRPr>
+            </a:pPr>
+            <a:r>
+              <a:t>       └─ {energy}_{dipole}/</a:t>
+            </a:r>
+          </a:p>
+          <a:p>
+            <a:pPr>
+              <a:lnSpc>
+                <a:spcPct val="100000"/>
+              </a:lnSpc>
+              <a:spcAft>
+                <a:spcPts val="600"/>
+              </a:spcAft>
+              <a:defRPr sz="1400">
+                <a:solidFill>
+                  <a:srgbClr val="C9D1D9"/>
+                </a:solidFill>
+                <a:latin typeface="Consolas"/>
+              </a:defRPr>
+            </a:pPr>
+          </a:p>
+          <a:p>
+            <a:pPr>
+              <a:lnSpc>
+                <a:spcPct val="100000"/>
+              </a:lnSpc>
+              <a:spcAft>
+                <a:spcPts val="600"/>
+              </a:spcAft>
+              <a:defRPr sz="1400">
+                <a:solidFill>
+                  <a:srgbClr val="C9D1D9"/>
+                </a:solidFill>
+                <a:latin typeface="Consolas"/>
+              </a:defRPr>
+            </a:pPr>
+            <a:r>
+              <a:t>  → Created on-the-fly</a:t>
+            </a:r>
+          </a:p>
+          <a:p>
+            <a:pPr>
+              <a:lnSpc>
+                <a:spcPct val="100000"/>
+              </a:lnSpc>
+              <a:spcAft>
+                <a:spcPts val="600"/>
+              </a:spcAft>
+              <a:defRPr sz="1400">
+                <a:solidFill>
+                  <a:srgbClr val="C9D1D9"/>
+                </a:solidFill>
+                <a:latin typeface="Consolas"/>
+              </a:defRPr>
+            </a:pPr>
+            <a:r>
+              <a:t>  → Organized by calculator combination</a:t>
+            </a:r>
+          </a:p>
+          <a:p>
+            <a:pPr>
+              <a:lnSpc>
+                <a:spcPct val="100000"/>
+              </a:lnSpc>
+              <a:spcAft>
+                <a:spcPts val="600"/>
+              </a:spcAft>
+              <a:defRPr sz="1400">
+                <a:solidFill>
+                  <a:srgbClr val="C9D1D9"/>
+                </a:solidFill>
+                <a:latin typeface="Consolas"/>
+              </a:defRPr>
+            </a:pPr>
+          </a:p>
+          <a:p>
+            <a:pPr>
+              <a:lnSpc>
+                <a:spcPct val="100000"/>
+              </a:lnSpc>
+              <a:spcAft>
+                <a:spcPts val="600"/>
+              </a:spcAft>
+              <a:defRPr sz="1400">
+                <a:solidFill>
+                  <a:srgbClr val="C9D1D9"/>
+                </a:solidFill>
+                <a:latin typeface="Consolas"/>
+              </a:defRPr>
+            </a:pPr>
+          </a:p>
+          <a:p>
+            <a:pPr>
+              <a:lnSpc>
+                <a:spcPct val="100000"/>
+              </a:lnSpc>
+              <a:spcAft>
+                <a:spcPts val="600"/>
+              </a:spcAft>
+              <a:defRPr sz="1400">
+                <a:solidFill>
+                  <a:srgbClr val="58A6FF"/>
+                </a:solidFill>
+                <a:latin typeface="Consolas"/>
+              </a:defRPr>
+            </a:pPr>
+            <a:r>
+              <a:t># Smart File Detection</a:t>
+            </a:r>
+          </a:p>
+          <a:p>
+            <a:pPr>
+              <a:lnSpc>
+                <a:spcPct val="100000"/>
+              </a:lnSpc>
+              <a:spcAft>
+                <a:spcPts val="600"/>
+              </a:spcAft>
+              <a:defRPr sz="1400">
+                <a:solidFill>
+                  <a:srgbClr val="C9D1D9"/>
+                </a:solidFill>
+                <a:latin typeface="Consolas"/>
+              </a:defRPr>
+            </a:pPr>
+          </a:p>
+          <a:p>
+            <a:pPr>
+              <a:lnSpc>
+                <a:spcPct val="100000"/>
+              </a:lnSpc>
+              <a:spcAft>
+                <a:spcPts val="600"/>
+              </a:spcAft>
+              <a:defRPr sz="1400">
+                <a:solidFill>
+                  <a:srgbClr val="C9D1D9"/>
+                </a:solidFill>
+                <a:latin typeface="Consolas"/>
+              </a:defRPr>
+            </a:pPr>
+            <a:r>
+              <a:t>  → Auto-detect existing calculations</a:t>
+            </a:r>
+          </a:p>
+          <a:p>
+            <a:pPr>
+              <a:lnSpc>
+                <a:spcPct val="100000"/>
+              </a:lnSpc>
+              <a:spcAft>
+                <a:spcPts val="600"/>
+              </a:spcAft>
+              <a:defRPr sz="1400">
+                <a:solidFill>
+                  <a:srgbClr val="C9D1D9"/>
+                </a:solidFill>
+                <a:latin typeface="Consolas"/>
+              </a:defRPr>
+            </a:pPr>
+            <a:r>
+              <a:t>  → Skip completed steps</a:t>
+            </a:r>
+          </a:p>
+          <a:p>
+            <a:pPr>
+              <a:lnSpc>
+                <a:spcPct val="100000"/>
+              </a:lnSpc>
+              <a:spcAft>
+                <a:spcPts val="600"/>
+              </a:spcAft>
+              <a:defRPr sz="1400">
+                <a:solidFill>
+                  <a:srgbClr val="C9D1D9"/>
+                </a:solidFill>
+                <a:latin typeface="Consolas"/>
+              </a:defRPr>
+            </a:pPr>
+            <a:r>
+              <a:t>  → Resume from interruption</a:t>
+            </a:r>
+          </a:p>
+          <a:p>
+            <a:pPr>
+              <a:lnSpc>
+                <a:spcPct val="100000"/>
+              </a:lnSpc>
+              <a:spcAft>
+                <a:spcPts val="600"/>
+              </a:spcAft>
+              <a:defRPr sz="1400">
+                <a:solidFill>
+                  <a:srgbClr val="C9D1D9"/>
+                </a:solidFill>
+                <a:latin typeface="Consolas"/>
+              </a:defRPr>
+            </a:pPr>
+            <a:r>
+              <a:t>  → Find DFT baseline automatically</a:t>
+            </a:r>
+          </a:p>
+          <a:p>
+            <a:pPr>
+              <a:lnSpc>
+                <a:spcPct val="100000"/>
+              </a:lnSpc>
+              <a:spcAft>
+                <a:spcPts val="600"/>
+              </a:spcAft>
+              <a:defRPr sz="1400">
+                <a:solidFill>
+                  <a:srgbClr val="C9D1D9"/>
+                </a:solidFill>
+                <a:latin typeface="Consolas"/>
+              </a:defRPr>
+            </a:pPr>
+          </a:p>
+          <a:p>
+            <a:pPr>
+              <a:lnSpc>
+                <a:spcPct val="100000"/>
+              </a:lnSpc>
+              <a:spcAft>
+                <a:spcPts val="600"/>
+              </a:spcAft>
+              <a:defRPr sz="1400">
+                <a:solidFill>
+                  <a:srgbClr val="C9D1D9"/>
+                </a:solidFill>
+                <a:latin typeface="Consolas"/>
+              </a:defRPr>
+            </a:pPr>
+          </a:p>
+          <a:p>
+            <a:pPr>
+              <a:lnSpc>
+                <a:spcPct val="100000"/>
+              </a:lnSpc>
+              <a:spcAft>
+                <a:spcPts val="600"/>
+              </a:spcAft>
+              <a:defRPr sz="1400">
+                <a:solidFill>
+                  <a:srgbClr val="58A6FF"/>
+                </a:solidFill>
+                <a:latin typeface="Consolas"/>
+              </a:defRPr>
+            </a:pPr>
+            <a:r>
+              <a:t># Results Aggregation</a:t>
+            </a:r>
+          </a:p>
+          <a:p>
+            <a:pPr>
+              <a:lnSpc>
+                <a:spcPct val="100000"/>
+              </a:lnSpc>
+              <a:spcAft>
+                <a:spcPts val="600"/>
+              </a:spcAft>
+              <a:defRPr sz="1400">
+                <a:solidFill>
+                  <a:srgbClr val="C9D1D9"/>
+                </a:solidFill>
+                <a:latin typeface="Consolas"/>
+              </a:defRPr>
+            </a:pPr>
+          </a:p>
+          <a:p>
+            <a:pPr>
+              <a:lnSpc>
+                <a:spcPct val="100000"/>
+              </a:lnSpc>
+              <a:spcAft>
+                <a:spcPts val="600"/>
+              </a:spcAft>
+              <a:defRPr sz="1400">
+                <a:solidFill>
+                  <a:srgbClr val="C9D1D9"/>
+                </a:solidFill>
+                <a:latin typeface="Consolas"/>
+              </a:defRPr>
+            </a:pPr>
+            <a:r>
+              <a:t>  → Load all JSON results</a:t>
+            </a:r>
+          </a:p>
+          <a:p>
+            <a:pPr>
+              <a:lnSpc>
+                <a:spcPct val="100000"/>
+              </a:lnSpc>
+              <a:spcAft>
+                <a:spcPts val="600"/>
+              </a:spcAft>
+              <a:defRPr sz="1400">
+                <a:solidFill>
+                  <a:srgbClr val="C9D1D9"/>
+                </a:solidFill>
+                <a:latin typeface="Consolas"/>
+              </a:defRPr>
+            </a:pPr>
+            <a:r>
+              <a:t>  → Parse all .log files</a:t>
+            </a:r>
+          </a:p>
+          <a:p>
+            <a:pPr>
+              <a:lnSpc>
+                <a:spcPct val="100000"/>
+              </a:lnSpc>
+              <a:spcAft>
+                <a:spcPts val="600"/>
+              </a:spcAft>
+              <a:defRPr sz="1400">
+                <a:solidFill>
+                  <a:srgbClr val="C9D1D9"/>
+                </a:solidFill>
+                <a:latin typeface="Consolas"/>
+              </a:defRPr>
+            </a:pPr>
+            <a:r>
+              <a:t>  → Match modes across methods</a:t>
+            </a:r>
+          </a:p>
+          <a:p>
+            <a:pPr>
+              <a:lnSpc>
+                <a:spcPct val="100000"/>
+              </a:lnSpc>
+              <a:spcAft>
+                <a:spcPts val="600"/>
+              </a:spcAft>
+              <a:defRPr sz="1400">
+                <a:solidFill>
+                  <a:srgbClr val="C9D1D9"/>
+                </a:solidFill>
+                <a:latin typeface="Consolas"/>
+              </a:defRPr>
+            </a:pPr>
+            <a:r>
+              <a:t>  → Generate unified HTML report</a:t>
             </a:r>
           </a:p>
         </p:txBody>

</xml_diff>